<commit_message>
Redesign presentation with soft, minimal aesthetic
Replaced dark pirate theme with clean light design:
- Warm off-white background with teal/coral accents
- Soft card-based layout with rounded corners
- Lighter typography hierarchy, no heavy decorations

https://claude.ai/code/session_01KapkgGDfwj8SdXnJxhq4Xb
</commit_message>
<xml_diff>
--- a/chateau_gonflable_pirate.pptx
+++ b/chateau_gonflable_pirate.pptx
@@ -3105,7 +3105,7 @@
             <a:avLst/>
           </a:prstGeom>
           <a:solidFill>
-            <a:srgbClr val="0A1F44"/>
+            <a:srgbClr val="FAF9F7"/>
           </a:solidFill>
           <a:ln>
             <a:noFill/>
@@ -3142,13 +3142,13 @@
         <p:spPr>
           <a:xfrm>
             <a:off x="0" y="0"/>
-            <a:ext cx="12188952" cy="109728"/>
+            <a:ext cx="4937760" cy="6858000"/>
           </a:xfrm>
           <a:prstGeom prst="rect">
             <a:avLst/>
           </a:prstGeom>
           <a:solidFill>
-            <a:srgbClr val="F5C518"/>
+            <a:srgbClr val="D6EDED"/>
           </a:solidFill>
           <a:ln>
             <a:noFill/>
@@ -3184,14 +3184,14 @@
         </p:nvSpPr>
         <p:spPr>
           <a:xfrm>
-            <a:off x="0" y="6748272"/>
-            <a:ext cx="12188952" cy="109728"/>
+            <a:off x="0" y="0"/>
+            <a:ext cx="54864" cy="6858000"/>
           </a:xfrm>
           <a:prstGeom prst="rect">
             <a:avLst/>
           </a:prstGeom>
           <a:solidFill>
-            <a:srgbClr val="F5C518"/>
+            <a:srgbClr val="4A9E9E"/>
           </a:solidFill>
           <a:ln>
             <a:noFill/>
@@ -3221,20 +3221,134 @@
       </p:sp>
       <p:sp>
         <p:nvSpPr>
-          <p:cNvPr id="5" name="Rectangle 4"/>
-          <p:cNvSpPr/>
-          <p:nvPr/>
-        </p:nvSpPr>
-        <p:spPr>
-          <a:xfrm>
-            <a:off x="0" y="109728"/>
-            <a:ext cx="73152" cy="6638544"/>
+          <p:cNvPr id="5" name="TextBox 4"/>
+          <p:cNvSpPr txBox="1"/>
+          <p:nvPr/>
+        </p:nvSpPr>
+        <p:spPr>
+          <a:xfrm>
+            <a:off x="411480" y="640080"/>
+            <a:ext cx="4206240" cy="457200"/>
           </a:xfrm>
           <a:prstGeom prst="rect">
             <a:avLst/>
           </a:prstGeom>
+          <a:noFill/>
+        </p:spPr>
+        <p:txBody>
+          <a:bodyPr wrap="square">
+            <a:spAutoFit/>
+          </a:bodyPr>
+          <a:lstStyle/>
+          <a:p>
+            <a:pPr algn="l"/>
+            <a:r>
+              <a:rPr sz="1000" b="1" i="0">
+                <a:solidFill>
+                  <a:srgbClr val="4A9E9E"/>
+                </a:solidFill>
+              </a:rPr>
+              <a:t>À VENDRE — OCCASION</a:t>
+            </a:r>
+          </a:p>
+        </p:txBody>
+      </p:sp>
+      <p:sp>
+        <p:nvSpPr>
+          <p:cNvPr id="6" name="TextBox 5"/>
+          <p:cNvSpPr txBox="1"/>
+          <p:nvPr/>
+        </p:nvSpPr>
+        <p:spPr>
+          <a:xfrm>
+            <a:off x="411480" y="1097280"/>
+            <a:ext cx="4206240" cy="2194560"/>
+          </a:xfrm>
+          <a:prstGeom prst="rect">
+            <a:avLst/>
+          </a:prstGeom>
+          <a:noFill/>
+        </p:spPr>
+        <p:txBody>
+          <a:bodyPr wrap="square">
+            <a:spAutoFit/>
+          </a:bodyPr>
+          <a:lstStyle/>
+          <a:p>
+            <a:pPr algn="l"/>
+            <a:r>
+              <a:rPr sz="4600" b="1">
+                <a:solidFill>
+                  <a:srgbClr val="2D2D2D"/>
+                </a:solidFill>
+              </a:rPr>
+              <a:t>Château
+Gonflable</a:t>
+            </a:r>
+          </a:p>
+          <a:p>
+            <a:pPr algn="l"/>
+            <a:r>
+              <a:rPr sz="4600" b="1">
+                <a:solidFill>
+                  <a:srgbClr val="4A9E9E"/>
+                </a:solidFill>
+              </a:rPr>
+              <a:t>Pirate</a:t>
+            </a:r>
+          </a:p>
+        </p:txBody>
+      </p:sp>
+      <p:sp>
+        <p:nvSpPr>
+          <p:cNvPr id="7" name="TextBox 6"/>
+          <p:cNvSpPr txBox="1"/>
+          <p:nvPr/>
+        </p:nvSpPr>
+        <p:spPr>
+          <a:xfrm>
+            <a:off x="411480" y="3429000"/>
+            <a:ext cx="4206240" cy="411480"/>
+          </a:xfrm>
+          <a:prstGeom prst="rect">
+            <a:avLst/>
+          </a:prstGeom>
+          <a:noFill/>
+        </p:spPr>
+        <p:txBody>
+          <a:bodyPr wrap="square">
+            <a:spAutoFit/>
+          </a:bodyPr>
+          <a:lstStyle/>
+          <a:p>
+            <a:pPr algn="l"/>
+            <a:r>
+              <a:rPr sz="1200" b="0" i="1">
+                <a:solidFill>
+                  <a:srgbClr val="7A7A7A"/>
+                </a:solidFill>
+              </a:rPr>
+              <a:t>Multiactivités · Toboggan · Escalade · Parcours</a:t>
+            </a:r>
+          </a:p>
+        </p:txBody>
+      </p:sp>
+      <p:sp>
+        <p:nvSpPr>
+          <p:cNvPr id="8" name="Rectangle 7"/>
+          <p:cNvSpPr/>
+          <p:nvPr/>
+        </p:nvSpPr>
+        <p:spPr>
+          <a:xfrm>
+            <a:off x="411480" y="3931920"/>
+            <a:ext cx="1828800" cy="27432"/>
+          </a:xfrm>
+          <a:prstGeom prst="rect">
+            <a:avLst/>
+          </a:prstGeom>
           <a:solidFill>
-            <a:srgbClr val="B88A00"/>
+            <a:srgbClr val="4A9E9E"/>
           </a:solidFill>
           <a:ln>
             <a:noFill/>
@@ -3264,20 +3378,90 @@
       </p:sp>
       <p:sp>
         <p:nvSpPr>
-          <p:cNvPr id="6" name="Rectangle 5"/>
-          <p:cNvSpPr/>
-          <p:nvPr/>
-        </p:nvSpPr>
-        <p:spPr>
-          <a:xfrm>
-            <a:off x="384048" y="804672"/>
-            <a:ext cx="7132320" cy="1417320"/>
+          <p:cNvPr id="9" name="TextBox 8"/>
+          <p:cNvSpPr txBox="1"/>
+          <p:nvPr/>
+        </p:nvSpPr>
+        <p:spPr>
+          <a:xfrm>
+            <a:off x="411480" y="4114800"/>
+            <a:ext cx="2286000" cy="365760"/>
           </a:xfrm>
           <a:prstGeom prst="rect">
             <a:avLst/>
           </a:prstGeom>
+          <a:noFill/>
+        </p:spPr>
+        <p:txBody>
+          <a:bodyPr wrap="square">
+            <a:spAutoFit/>
+          </a:bodyPr>
+          <a:lstStyle/>
+          <a:p>
+            <a:pPr algn="l"/>
+            <a:r>
+              <a:rPr sz="1000" b="0" i="0">
+                <a:solidFill>
+                  <a:srgbClr val="7A7A7A"/>
+                </a:solidFill>
+              </a:rPr>
+              <a:t>Prix de vente HT</a:t>
+            </a:r>
+          </a:p>
+        </p:txBody>
+      </p:sp>
+      <p:sp>
+        <p:nvSpPr>
+          <p:cNvPr id="10" name="TextBox 9"/>
+          <p:cNvSpPr txBox="1"/>
+          <p:nvPr/>
+        </p:nvSpPr>
+        <p:spPr>
+          <a:xfrm>
+            <a:off x="411480" y="4434840"/>
+            <a:ext cx="3657600" cy="685800"/>
+          </a:xfrm>
+          <a:prstGeom prst="rect">
+            <a:avLst/>
+          </a:prstGeom>
+          <a:noFill/>
+        </p:spPr>
+        <p:txBody>
+          <a:bodyPr wrap="square">
+            <a:spAutoFit/>
+          </a:bodyPr>
+          <a:lstStyle/>
+          <a:p>
+            <a:pPr algn="l"/>
+            <a:r>
+              <a:rPr sz="3800" b="1" i="0">
+                <a:solidFill>
+                  <a:srgbClr val="E87B6A"/>
+                </a:solidFill>
+              </a:rPr>
+              <a:t>1 700,00 €</a:t>
+            </a:r>
+          </a:p>
+        </p:txBody>
+      </p:sp>
+      <p:sp>
+        <p:nvSpPr>
+          <p:cNvPr id="11" name="Rounded Rectangle 10"/>
+          <p:cNvSpPr/>
+          <p:nvPr/>
+        </p:nvSpPr>
+        <p:spPr>
+          <a:xfrm>
+            <a:off x="411480" y="5257800"/>
+            <a:ext cx="1828800" cy="384048"/>
+          </a:xfrm>
+          <a:prstGeom prst="roundRect">
+            <a:avLst>
+              <a:gd name="adj" fmla="val 8000"/>
+            </a:avLst>
+          </a:prstGeom>
           <a:solidFill>
-            <a:srgbClr val="051025"/>
+            <a:srgbClr val="D6EDED"/>
           </a:solidFill>
           <a:ln>
             <a:noFill/>
@@ -3307,59 +3491,14 @@
       </p:sp>
       <p:sp>
         <p:nvSpPr>
-          <p:cNvPr id="7" name="TextBox 6"/>
+          <p:cNvPr id="12" name="TextBox 11"/>
           <p:cNvSpPr txBox="1"/>
           <p:nvPr/>
         </p:nvSpPr>
         <p:spPr>
           <a:xfrm>
-            <a:off x="365760" y="777240"/>
-            <a:ext cx="7132320" cy="1463040"/>
-          </a:xfrm>
-          <a:prstGeom prst="rect">
-            <a:avLst/>
-          </a:prstGeom>
-          <a:noFill/>
-        </p:spPr>
-        <p:txBody>
-          <a:bodyPr wrap="none">
-            <a:spAutoFit/>
-          </a:bodyPr>
-          <a:lstStyle/>
-          <a:p>
-            <a:pPr algn="l"/>
-            <a:r>
-              <a:rPr sz="5200" b="1">
-                <a:solidFill>
-                  <a:srgbClr val="FFFFFF"/>
-                </a:solidFill>
-              </a:rPr>
-              <a:t>Château Gonflable</a:t>
-            </a:r>
-          </a:p>
-          <a:p>
-            <a:pPr algn="l"/>
-            <a:r>
-              <a:rPr sz="6200" b="1">
-                <a:solidFill>
-                  <a:srgbClr val="F5C518"/>
-                </a:solidFill>
-              </a:rPr>
-              <a:t>Pirate</a:t>
-            </a:r>
-          </a:p>
-        </p:txBody>
-      </p:sp>
-      <p:sp>
-        <p:nvSpPr>
-          <p:cNvPr id="8" name="TextBox 7"/>
-          <p:cNvSpPr txBox="1"/>
-          <p:nvPr/>
-        </p:nvSpPr>
-        <p:spPr>
-          <a:xfrm>
-            <a:off x="365760" y="274320"/>
-            <a:ext cx="1828800" cy="548640"/>
+            <a:off x="502920" y="5321808"/>
+            <a:ext cx="1737360" cy="292608"/>
           </a:xfrm>
           <a:prstGeom prst="rect">
             <a:avLst/>
@@ -3372,36 +3511,34 @@
           </a:bodyPr>
           <a:lstStyle/>
           <a:p>
-            <a:pPr algn="l"/>
-            <a:r>
-              <a:rPr sz="1300" b="1" i="0">
+            <a:pPr algn="ctr"/>
+            <a:r>
+              <a:rPr sz="1000" b="1" i="0">
                 <a:solidFill>
-                  <a:srgbClr val="F5C518"/>
+                  <a:srgbClr val="4A9E9E"/>
                 </a:solidFill>
               </a:rPr>
-              <a:t>☠  Occasion — Stock limité  ☠</a:t>
-            </a:r>
-          </a:p>
-        </p:txBody>
-      </p:sp>
-      <p:sp>
-        <p:nvSpPr>
-          <p:cNvPr id="9" name="Rounded Rectangle 8"/>
+              <a:t>Conforme EN 14960</a:t>
+            </a:r>
+          </a:p>
+        </p:txBody>
+      </p:sp>
+      <p:sp>
+        <p:nvSpPr>
+          <p:cNvPr id="13" name="Rectangle 12"/>
           <p:cNvSpPr/>
           <p:nvPr/>
         </p:nvSpPr>
         <p:spPr>
           <a:xfrm>
-            <a:off x="365760" y="2423160"/>
-            <a:ext cx="3108960" cy="1005840"/>
-          </a:xfrm>
-          <a:prstGeom prst="roundRect">
-            <a:avLst>
-              <a:gd name="adj" fmla="val 5000"/>
-            </a:avLst>
+            <a:off x="5029200" y="0"/>
+            <a:ext cx="7159752" cy="6858000"/>
+          </a:xfrm>
+          <a:prstGeom prst="rect">
+            <a:avLst/>
           </a:prstGeom>
           <a:solidFill>
-            <a:srgbClr val="CC1F1F"/>
+            <a:srgbClr val="F2EEE8"/>
           </a:solidFill>
           <a:ln>
             <a:noFill/>
@@ -3431,124 +3568,22 @@
       </p:sp>
       <p:sp>
         <p:nvSpPr>
-          <p:cNvPr id="10" name="TextBox 9"/>
-          <p:cNvSpPr txBox="1"/>
-          <p:nvPr/>
-        </p:nvSpPr>
-        <p:spPr>
-          <a:xfrm>
-            <a:off x="365760" y="2450592"/>
-            <a:ext cx="3108960" cy="411480"/>
-          </a:xfrm>
-          <a:prstGeom prst="rect">
-            <a:avLst/>
-          </a:prstGeom>
-          <a:noFill/>
-        </p:spPr>
-        <p:txBody>
-          <a:bodyPr wrap="square">
-            <a:spAutoFit/>
-          </a:bodyPr>
-          <a:lstStyle/>
-          <a:p>
-            <a:pPr algn="ctr"/>
-            <a:r>
-              <a:rPr sz="1400" b="0" i="0">
-                <a:solidFill>
-                  <a:srgbClr val="FFFFFF"/>
-                </a:solidFill>
-              </a:rPr>
-              <a:t>Prix HT</a:t>
-            </a:r>
-          </a:p>
-        </p:txBody>
-      </p:sp>
-      <p:sp>
-        <p:nvSpPr>
-          <p:cNvPr id="11" name="TextBox 10"/>
-          <p:cNvSpPr txBox="1"/>
-          <p:nvPr/>
-        </p:nvSpPr>
-        <p:spPr>
-          <a:xfrm>
-            <a:off x="365760" y="2761488"/>
-            <a:ext cx="3108960" cy="640080"/>
-          </a:xfrm>
-          <a:prstGeom prst="rect">
-            <a:avLst/>
-          </a:prstGeom>
-          <a:noFill/>
-        </p:spPr>
-        <p:txBody>
-          <a:bodyPr wrap="square">
-            <a:spAutoFit/>
-          </a:bodyPr>
-          <a:lstStyle/>
-          <a:p>
-            <a:pPr algn="ctr"/>
-            <a:r>
-              <a:rPr sz="3400" b="1" i="0">
-                <a:solidFill>
-                  <a:srgbClr val="FFFFFF"/>
-                </a:solidFill>
-              </a:rPr>
-              <a:t>1 700,00 €</a:t>
-            </a:r>
-          </a:p>
-        </p:txBody>
-      </p:sp>
-      <p:sp>
-        <p:nvSpPr>
-          <p:cNvPr id="12" name="TextBox 11"/>
-          <p:cNvSpPr txBox="1"/>
-          <p:nvPr/>
-        </p:nvSpPr>
-        <p:spPr>
-          <a:xfrm>
-            <a:off x="365760" y="3611880"/>
-            <a:ext cx="5486400" cy="457200"/>
-          </a:xfrm>
-          <a:prstGeom prst="rect">
-            <a:avLst/>
-          </a:prstGeom>
-          <a:noFill/>
-        </p:spPr>
-        <p:txBody>
-          <a:bodyPr wrap="square">
-            <a:spAutoFit/>
-          </a:bodyPr>
-          <a:lstStyle/>
-          <a:p>
-            <a:pPr algn="l"/>
-            <a:r>
-              <a:rPr sz="1500" b="0" i="1">
-                <a:solidFill>
-                  <a:srgbClr val="D6EAF8"/>
-                </a:solidFill>
-              </a:rPr>
-              <a:t>Multiactivités · Toboggan · Escalade · Parcours</a:t>
-            </a:r>
-          </a:p>
-        </p:txBody>
-      </p:sp>
-      <p:sp>
-        <p:nvSpPr>
-          <p:cNvPr id="13" name="Rounded Rectangle 12"/>
+          <p:cNvPr id="14" name="Rounded Rectangle 13"/>
           <p:cNvSpPr/>
           <p:nvPr/>
         </p:nvSpPr>
         <p:spPr>
           <a:xfrm>
-            <a:off x="365760" y="4206240"/>
-            <a:ext cx="5120640" cy="2331720"/>
+            <a:off x="5486400" y="548640"/>
+            <a:ext cx="6309360" cy="5760720"/>
           </a:xfrm>
           <a:prstGeom prst="roundRect">
             <a:avLst>
-              <a:gd name="adj" fmla="val 5000"/>
+              <a:gd name="adj" fmla="val 4000"/>
             </a:avLst>
           </a:prstGeom>
           <a:solidFill>
-            <a:srgbClr val="102A5E"/>
+            <a:srgbClr val="FFFFFF"/>
           </a:solidFill>
           <a:ln>
             <a:noFill/>
@@ -3578,14 +3613,14 @@
       </p:sp>
       <p:sp>
         <p:nvSpPr>
-          <p:cNvPr id="14" name="TextBox 13"/>
+          <p:cNvPr id="15" name="TextBox 14"/>
           <p:cNvSpPr txBox="1"/>
           <p:nvPr/>
         </p:nvSpPr>
         <p:spPr>
           <a:xfrm>
-            <a:off x="502920" y="4297680"/>
-            <a:ext cx="411480" cy="438912"/>
+            <a:off x="5486400" y="3291840"/>
+            <a:ext cx="6309360" cy="457200"/>
           </a:xfrm>
           <a:prstGeom prst="rect">
             <a:avLst/>
@@ -3598,28 +3633,28 @@
           </a:bodyPr>
           <a:lstStyle/>
           <a:p>
-            <a:pPr algn="l"/>
-            <a:r>
-              <a:rPr sz="1800" b="0" i="0">
+            <a:pPr algn="ctr"/>
+            <a:r>
+              <a:rPr sz="1600" b="0" i="1">
                 <a:solidFill>
-                  <a:srgbClr val="F5C518"/>
+                  <a:srgbClr val="EEECE9"/>
                 </a:solidFill>
               </a:rPr>
-              <a:t>📐</a:t>
-            </a:r>
-          </a:p>
-        </p:txBody>
-      </p:sp>
-      <p:sp>
-        <p:nvSpPr>
-          <p:cNvPr id="15" name="TextBox 14"/>
+              <a:t>[ Image produit ]</a:t>
+            </a:r>
+          </a:p>
+        </p:txBody>
+      </p:sp>
+      <p:sp>
+        <p:nvSpPr>
+          <p:cNvPr id="16" name="TextBox 15"/>
           <p:cNvSpPr txBox="1"/>
           <p:nvPr/>
         </p:nvSpPr>
         <p:spPr>
           <a:xfrm>
-            <a:off x="868680" y="4297680"/>
-            <a:ext cx="1463040" cy="438912"/>
+            <a:off x="411480" y="6537960"/>
+            <a:ext cx="11430000" cy="274320"/>
           </a:xfrm>
           <a:prstGeom prst="rect">
             <a:avLst/>
@@ -3634,637 +3669,12 @@
           <a:p>
             <a:pPr algn="l"/>
             <a:r>
-              <a:rPr sz="1300" b="1" i="0">
+              <a:rPr sz="800" b="0" i="0">
                 <a:solidFill>
-                  <a:srgbClr val="F5C518"/>
+                  <a:srgbClr val="7A7A7A"/>
                 </a:solidFill>
               </a:rPr>
-              <a:t>Dimensions :</a:t>
-            </a:r>
-          </a:p>
-        </p:txBody>
-      </p:sp>
-      <p:sp>
-        <p:nvSpPr>
-          <p:cNvPr id="16" name="TextBox 15"/>
-          <p:cNvSpPr txBox="1"/>
-          <p:nvPr/>
-        </p:nvSpPr>
-        <p:spPr>
-          <a:xfrm>
-            <a:off x="2331720" y="4297680"/>
-            <a:ext cx="3017520" cy="438912"/>
-          </a:xfrm>
-          <a:prstGeom prst="rect">
-            <a:avLst/>
-          </a:prstGeom>
-          <a:noFill/>
-        </p:spPr>
-        <p:txBody>
-          <a:bodyPr wrap="square">
-            <a:spAutoFit/>
-          </a:bodyPr>
-          <a:lstStyle/>
-          <a:p>
-            <a:pPr algn="l"/>
-            <a:r>
-              <a:rPr sz="1300" b="0" i="0">
-                <a:solidFill>
-                  <a:srgbClr val="FFFFFF"/>
-                </a:solidFill>
-              </a:rPr>
-              <a:t>L 8 m × P 5,1 m × H 4,3 m</a:t>
-            </a:r>
-          </a:p>
-        </p:txBody>
-      </p:sp>
-      <p:sp>
-        <p:nvSpPr>
-          <p:cNvPr id="17" name="TextBox 16"/>
-          <p:cNvSpPr txBox="1"/>
-          <p:nvPr/>
-        </p:nvSpPr>
-        <p:spPr>
-          <a:xfrm>
-            <a:off x="502920" y="4828032"/>
-            <a:ext cx="411480" cy="438912"/>
-          </a:xfrm>
-          <a:prstGeom prst="rect">
-            <a:avLst/>
-          </a:prstGeom>
-          <a:noFill/>
-        </p:spPr>
-        <p:txBody>
-          <a:bodyPr wrap="square">
-            <a:spAutoFit/>
-          </a:bodyPr>
-          <a:lstStyle/>
-          <a:p>
-            <a:pPr algn="l"/>
-            <a:r>
-              <a:rPr sz="1800" b="0" i="0">
-                <a:solidFill>
-                  <a:srgbClr val="F5C518"/>
-                </a:solidFill>
-              </a:rPr>
-              <a:t>⚡</a:t>
-            </a:r>
-          </a:p>
-        </p:txBody>
-      </p:sp>
-      <p:sp>
-        <p:nvSpPr>
-          <p:cNvPr id="18" name="TextBox 17"/>
-          <p:cNvSpPr txBox="1"/>
-          <p:nvPr/>
-        </p:nvSpPr>
-        <p:spPr>
-          <a:xfrm>
-            <a:off x="868680" y="4828032"/>
-            <a:ext cx="1463040" cy="438912"/>
-          </a:xfrm>
-          <a:prstGeom prst="rect">
-            <a:avLst/>
-          </a:prstGeom>
-          <a:noFill/>
-        </p:spPr>
-        <p:txBody>
-          <a:bodyPr wrap="square">
-            <a:spAutoFit/>
-          </a:bodyPr>
-          <a:lstStyle/>
-          <a:p>
-            <a:pPr algn="l"/>
-            <a:r>
-              <a:rPr sz="1300" b="1" i="0">
-                <a:solidFill>
-                  <a:srgbClr val="F5C518"/>
-                </a:solidFill>
-              </a:rPr>
-              <a:t>Alimentation :</a:t>
-            </a:r>
-          </a:p>
-        </p:txBody>
-      </p:sp>
-      <p:sp>
-        <p:nvSpPr>
-          <p:cNvPr id="19" name="TextBox 18"/>
-          <p:cNvSpPr txBox="1"/>
-          <p:nvPr/>
-        </p:nvSpPr>
-        <p:spPr>
-          <a:xfrm>
-            <a:off x="2331720" y="4828032"/>
-            <a:ext cx="3017520" cy="438912"/>
-          </a:xfrm>
-          <a:prstGeom prst="rect">
-            <a:avLst/>
-          </a:prstGeom>
-          <a:noFill/>
-        </p:spPr>
-        <p:txBody>
-          <a:bodyPr wrap="square">
-            <a:spAutoFit/>
-          </a:bodyPr>
-          <a:lstStyle/>
-          <a:p>
-            <a:pPr algn="l"/>
-            <a:r>
-              <a:rPr sz="1300" b="0" i="0">
-                <a:solidFill>
-                  <a:srgbClr val="FFFFFF"/>
-                </a:solidFill>
-              </a:rPr>
-              <a:t>220 V / 16 A (prise standard)</a:t>
-            </a:r>
-          </a:p>
-        </p:txBody>
-      </p:sp>
-      <p:sp>
-        <p:nvSpPr>
-          <p:cNvPr id="20" name="TextBox 19"/>
-          <p:cNvSpPr txBox="1"/>
-          <p:nvPr/>
-        </p:nvSpPr>
-        <p:spPr>
-          <a:xfrm>
-            <a:off x="502920" y="5358384"/>
-            <a:ext cx="411480" cy="438912"/>
-          </a:xfrm>
-          <a:prstGeom prst="rect">
-            <a:avLst/>
-          </a:prstGeom>
-          <a:noFill/>
-        </p:spPr>
-        <p:txBody>
-          <a:bodyPr wrap="square">
-            <a:spAutoFit/>
-          </a:bodyPr>
-          <a:lstStyle/>
-          <a:p>
-            <a:pPr algn="l"/>
-            <a:r>
-              <a:rPr sz="1800" b="0" i="0">
-                <a:solidFill>
-                  <a:srgbClr val="F5C518"/>
-                </a:solidFill>
-              </a:rPr>
-              <a:t>👥</a:t>
-            </a:r>
-          </a:p>
-        </p:txBody>
-      </p:sp>
-      <p:sp>
-        <p:nvSpPr>
-          <p:cNvPr id="21" name="TextBox 20"/>
-          <p:cNvSpPr txBox="1"/>
-          <p:nvPr/>
-        </p:nvSpPr>
-        <p:spPr>
-          <a:xfrm>
-            <a:off x="868680" y="5358384"/>
-            <a:ext cx="1463040" cy="438912"/>
-          </a:xfrm>
-          <a:prstGeom prst="rect">
-            <a:avLst/>
-          </a:prstGeom>
-          <a:noFill/>
-        </p:spPr>
-        <p:txBody>
-          <a:bodyPr wrap="square">
-            <a:spAutoFit/>
-          </a:bodyPr>
-          <a:lstStyle/>
-          <a:p>
-            <a:pPr algn="l"/>
-            <a:r>
-              <a:rPr sz="1300" b="1" i="0">
-                <a:solidFill>
-                  <a:srgbClr val="F5C518"/>
-                </a:solidFill>
-              </a:rPr>
-              <a:t>Capacité max :</a:t>
-            </a:r>
-          </a:p>
-        </p:txBody>
-      </p:sp>
-      <p:sp>
-        <p:nvSpPr>
-          <p:cNvPr id="22" name="TextBox 21"/>
-          <p:cNvSpPr txBox="1"/>
-          <p:nvPr/>
-        </p:nvSpPr>
-        <p:spPr>
-          <a:xfrm>
-            <a:off x="2331720" y="5358384"/>
-            <a:ext cx="3017520" cy="438912"/>
-          </a:xfrm>
-          <a:prstGeom prst="rect">
-            <a:avLst/>
-          </a:prstGeom>
-          <a:noFill/>
-        </p:spPr>
-        <p:txBody>
-          <a:bodyPr wrap="square">
-            <a:spAutoFit/>
-          </a:bodyPr>
-          <a:lstStyle/>
-          <a:p>
-            <a:pPr algn="l"/>
-            <a:r>
-              <a:rPr sz="1300" b="0" i="0">
-                <a:solidFill>
-                  <a:srgbClr val="FFFFFF"/>
-                </a:solidFill>
-              </a:rPr>
-              <a:t>12 enfants  ou  6 adultes</a:t>
-            </a:r>
-          </a:p>
-        </p:txBody>
-      </p:sp>
-      <p:sp>
-        <p:nvSpPr>
-          <p:cNvPr id="23" name="TextBox 22"/>
-          <p:cNvSpPr txBox="1"/>
-          <p:nvPr/>
-        </p:nvSpPr>
-        <p:spPr>
-          <a:xfrm>
-            <a:off x="502920" y="5888736"/>
-            <a:ext cx="411480" cy="438912"/>
-          </a:xfrm>
-          <a:prstGeom prst="rect">
-            <a:avLst/>
-          </a:prstGeom>
-          <a:noFill/>
-        </p:spPr>
-        <p:txBody>
-          <a:bodyPr wrap="square">
-            <a:spAutoFit/>
-          </a:bodyPr>
-          <a:lstStyle/>
-          <a:p>
-            <a:pPr algn="l"/>
-            <a:r>
-              <a:rPr sz="1800" b="0" i="0">
-                <a:solidFill>
-                  <a:srgbClr val="F5C518"/>
-                </a:solidFill>
-              </a:rPr>
-              <a:t>✅</a:t>
-            </a:r>
-          </a:p>
-        </p:txBody>
-      </p:sp>
-      <p:sp>
-        <p:nvSpPr>
-          <p:cNvPr id="24" name="TextBox 23"/>
-          <p:cNvSpPr txBox="1"/>
-          <p:nvPr/>
-        </p:nvSpPr>
-        <p:spPr>
-          <a:xfrm>
-            <a:off x="868680" y="5888736"/>
-            <a:ext cx="1463040" cy="438912"/>
-          </a:xfrm>
-          <a:prstGeom prst="rect">
-            <a:avLst/>
-          </a:prstGeom>
-          <a:noFill/>
-        </p:spPr>
-        <p:txBody>
-          <a:bodyPr wrap="square">
-            <a:spAutoFit/>
-          </a:bodyPr>
-          <a:lstStyle/>
-          <a:p>
-            <a:pPr algn="l"/>
-            <a:r>
-              <a:rPr sz="1300" b="1" i="0">
-                <a:solidFill>
-                  <a:srgbClr val="F5C518"/>
-                </a:solidFill>
-              </a:rPr>
-              <a:t>Norme :</a:t>
-            </a:r>
-          </a:p>
-        </p:txBody>
-      </p:sp>
-      <p:sp>
-        <p:nvSpPr>
-          <p:cNvPr id="25" name="TextBox 24"/>
-          <p:cNvSpPr txBox="1"/>
-          <p:nvPr/>
-        </p:nvSpPr>
-        <p:spPr>
-          <a:xfrm>
-            <a:off x="2331720" y="5888736"/>
-            <a:ext cx="3017520" cy="438912"/>
-          </a:xfrm>
-          <a:prstGeom prst="rect">
-            <a:avLst/>
-          </a:prstGeom>
-          <a:noFill/>
-        </p:spPr>
-        <p:txBody>
-          <a:bodyPr wrap="square">
-            <a:spAutoFit/>
-          </a:bodyPr>
-          <a:lstStyle/>
-          <a:p>
-            <a:pPr algn="l"/>
-            <a:r>
-              <a:rPr sz="1300" b="0" i="0">
-                <a:solidFill>
-                  <a:srgbClr val="FFFFFF"/>
-                </a:solidFill>
-              </a:rPr>
-              <a:t>Conforme EN 14960</a:t>
-            </a:r>
-          </a:p>
-        </p:txBody>
-      </p:sp>
-      <p:sp>
-        <p:nvSpPr>
-          <p:cNvPr id="26" name="Rounded Rectangle 25"/>
-          <p:cNvSpPr/>
-          <p:nvPr/>
-        </p:nvSpPr>
-        <p:spPr>
-          <a:xfrm>
-            <a:off x="5943600" y="457200"/>
-            <a:ext cx="5943600" cy="6035040"/>
-          </a:xfrm>
-          <a:prstGeom prst="roundRect">
-            <a:avLst>
-              <a:gd name="adj" fmla="val 5000"/>
-            </a:avLst>
-          </a:prstGeom>
-          <a:solidFill>
-            <a:srgbClr val="122B5E"/>
-          </a:solidFill>
-          <a:ln>
-            <a:noFill/>
-          </a:ln>
-        </p:spPr>
-        <p:style>
-          <a:lnRef idx="1">
-            <a:schemeClr val="accent1"/>
-          </a:lnRef>
-          <a:fillRef idx="3">
-            <a:schemeClr val="accent1"/>
-          </a:fillRef>
-          <a:effectRef idx="2">
-            <a:schemeClr val="accent1"/>
-          </a:effectRef>
-          <a:fontRef idx="minor">
-            <a:schemeClr val="lt1"/>
-          </a:fontRef>
-        </p:style>
-        <p:txBody>
-          <a:bodyPr rtlCol="0" anchor="ctr"/>
-          <a:lstStyle/>
-          <a:p>
-            <a:pPr algn="ctr"/>
-          </a:p>
-        </p:txBody>
-      </p:sp>
-      <p:sp>
-        <p:nvSpPr>
-          <p:cNvPr id="27" name="Rectangle 26"/>
-          <p:cNvSpPr/>
-          <p:nvPr/>
-        </p:nvSpPr>
-        <p:spPr>
-          <a:xfrm>
-            <a:off x="5943600" y="457200"/>
-            <a:ext cx="5943600" cy="45720"/>
-          </a:xfrm>
-          <a:prstGeom prst="rect">
-            <a:avLst/>
-          </a:prstGeom>
-          <a:solidFill>
-            <a:srgbClr val="F5C518"/>
-          </a:solidFill>
-          <a:ln>
-            <a:noFill/>
-          </a:ln>
-        </p:spPr>
-        <p:style>
-          <a:lnRef idx="1">
-            <a:schemeClr val="accent1"/>
-          </a:lnRef>
-          <a:fillRef idx="3">
-            <a:schemeClr val="accent1"/>
-          </a:fillRef>
-          <a:effectRef idx="2">
-            <a:schemeClr val="accent1"/>
-          </a:effectRef>
-          <a:fontRef idx="minor">
-            <a:schemeClr val="lt1"/>
-          </a:fontRef>
-        </p:style>
-        <p:txBody>
-          <a:bodyPr rtlCol="0" anchor="ctr"/>
-          <a:lstStyle/>
-          <a:p>
-            <a:pPr algn="ctr"/>
-          </a:p>
-        </p:txBody>
-      </p:sp>
-      <p:sp>
-        <p:nvSpPr>
-          <p:cNvPr id="28" name="Rectangle 27"/>
-          <p:cNvSpPr/>
-          <p:nvPr/>
-        </p:nvSpPr>
-        <p:spPr>
-          <a:xfrm>
-            <a:off x="5943600" y="6446520"/>
-            <a:ext cx="5943600" cy="45720"/>
-          </a:xfrm>
-          <a:prstGeom prst="rect">
-            <a:avLst/>
-          </a:prstGeom>
-          <a:solidFill>
-            <a:srgbClr val="F5C518"/>
-          </a:solidFill>
-          <a:ln>
-            <a:noFill/>
-          </a:ln>
-        </p:spPr>
-        <p:style>
-          <a:lnRef idx="1">
-            <a:schemeClr val="accent1"/>
-          </a:lnRef>
-          <a:fillRef idx="3">
-            <a:schemeClr val="accent1"/>
-          </a:fillRef>
-          <a:effectRef idx="2">
-            <a:schemeClr val="accent1"/>
-          </a:effectRef>
-          <a:fontRef idx="minor">
-            <a:schemeClr val="lt1"/>
-          </a:fontRef>
-        </p:style>
-        <p:txBody>
-          <a:bodyPr rtlCol="0" anchor="ctr"/>
-          <a:lstStyle/>
-          <a:p>
-            <a:pPr algn="ctr"/>
-          </a:p>
-        </p:txBody>
-      </p:sp>
-      <p:sp>
-        <p:nvSpPr>
-          <p:cNvPr id="29" name="Rectangle 28"/>
-          <p:cNvSpPr/>
-          <p:nvPr/>
-        </p:nvSpPr>
-        <p:spPr>
-          <a:xfrm>
-            <a:off x="5943600" y="457200"/>
-            <a:ext cx="45720" cy="6035040"/>
-          </a:xfrm>
-          <a:prstGeom prst="rect">
-            <a:avLst/>
-          </a:prstGeom>
-          <a:solidFill>
-            <a:srgbClr val="F5C518"/>
-          </a:solidFill>
-          <a:ln>
-            <a:noFill/>
-          </a:ln>
-        </p:spPr>
-        <p:style>
-          <a:lnRef idx="1">
-            <a:schemeClr val="accent1"/>
-          </a:lnRef>
-          <a:fillRef idx="3">
-            <a:schemeClr val="accent1"/>
-          </a:fillRef>
-          <a:effectRef idx="2">
-            <a:schemeClr val="accent1"/>
-          </a:effectRef>
-          <a:fontRef idx="minor">
-            <a:schemeClr val="lt1"/>
-          </a:fontRef>
-        </p:style>
-        <p:txBody>
-          <a:bodyPr rtlCol="0" anchor="ctr"/>
-          <a:lstStyle/>
-          <a:p>
-            <a:pPr algn="ctr"/>
-          </a:p>
-        </p:txBody>
-      </p:sp>
-      <p:sp>
-        <p:nvSpPr>
-          <p:cNvPr id="30" name="Rectangle 29"/>
-          <p:cNvSpPr/>
-          <p:nvPr/>
-        </p:nvSpPr>
-        <p:spPr>
-          <a:xfrm>
-            <a:off x="11841480" y="457200"/>
-            <a:ext cx="45720" cy="6035040"/>
-          </a:xfrm>
-          <a:prstGeom prst="rect">
-            <a:avLst/>
-          </a:prstGeom>
-          <a:solidFill>
-            <a:srgbClr val="F5C518"/>
-          </a:solidFill>
-          <a:ln>
-            <a:noFill/>
-          </a:ln>
-        </p:spPr>
-        <p:style>
-          <a:lnRef idx="1">
-            <a:schemeClr val="accent1"/>
-          </a:lnRef>
-          <a:fillRef idx="3">
-            <a:schemeClr val="accent1"/>
-          </a:fillRef>
-          <a:effectRef idx="2">
-            <a:schemeClr val="accent1"/>
-          </a:effectRef>
-          <a:fontRef idx="minor">
-            <a:schemeClr val="lt1"/>
-          </a:fontRef>
-        </p:style>
-        <p:txBody>
-          <a:bodyPr rtlCol="0" anchor="ctr"/>
-          <a:lstStyle/>
-          <a:p>
-            <a:pPr algn="ctr"/>
-          </a:p>
-        </p:txBody>
-      </p:sp>
-      <p:sp>
-        <p:nvSpPr>
-          <p:cNvPr id="31" name="TextBox 30"/>
-          <p:cNvSpPr txBox="1"/>
-          <p:nvPr/>
-        </p:nvSpPr>
-        <p:spPr>
-          <a:xfrm>
-            <a:off x="5989320" y="3017520"/>
-            <a:ext cx="5852160" cy="822960"/>
-          </a:xfrm>
-          <a:prstGeom prst="rect">
-            <a:avLst/>
-          </a:prstGeom>
-          <a:noFill/>
-        </p:spPr>
-        <p:txBody>
-          <a:bodyPr wrap="square">
-            <a:spAutoFit/>
-          </a:bodyPr>
-          <a:lstStyle/>
-          <a:p>
-            <a:pPr algn="ctr"/>
-            <a:r>
-              <a:rPr sz="2000" b="0" i="1">
-                <a:solidFill>
-                  <a:srgbClr val="5A7AAA"/>
-                </a:solidFill>
-              </a:rPr>
-              <a:t>[ Image produit ]</a:t>
-            </a:r>
-          </a:p>
-        </p:txBody>
-      </p:sp>
-      <p:sp>
-        <p:nvSpPr>
-          <p:cNvPr id="32" name="TextBox 31"/>
-          <p:cNvSpPr txBox="1"/>
-          <p:nvPr/>
-        </p:nvSpPr>
-        <p:spPr>
-          <a:xfrm>
-            <a:off x="365760" y="6492240"/>
-            <a:ext cx="11430000" cy="320040"/>
-          </a:xfrm>
-          <a:prstGeom prst="rect">
-            <a:avLst/>
-          </a:prstGeom>
-          <a:noFill/>
-        </p:spPr>
-        <p:txBody>
-          <a:bodyPr wrap="square">
-            <a:spAutoFit/>
-          </a:bodyPr>
-          <a:lstStyle/>
-          <a:p>
-            <a:pPr algn="l"/>
-            <a:r>
-              <a:rPr sz="900" b="0" i="0">
-                <a:solidFill>
-                  <a:srgbClr val="88AACC"/>
-                </a:solidFill>
-              </a:rPr>
-              <a:t>Source : https://jeux-gonflables.net — Parcours gonflable occasion #1359</a:t>
+              <a:t>jeux-gonflables.net — Parcours gonflable occasion #1359</a:t>
             </a:r>
           </a:p>
         </p:txBody>
@@ -4302,7 +3712,7 @@
             <a:avLst/>
           </a:prstGeom>
           <a:solidFill>
-            <a:srgbClr val="0A1F44"/>
+            <a:srgbClr val="FAF9F7"/>
           </a:solidFill>
           <a:ln>
             <a:noFill/>
@@ -4339,13 +3749,13 @@
         <p:spPr>
           <a:xfrm>
             <a:off x="0" y="0"/>
-            <a:ext cx="12188952" cy="109728"/>
+            <a:ext cx="54864" cy="6858000"/>
           </a:xfrm>
           <a:prstGeom prst="rect">
             <a:avLst/>
           </a:prstGeom>
           <a:solidFill>
-            <a:srgbClr val="F5C518"/>
+            <a:srgbClr val="4A9E9E"/>
           </a:solidFill>
           <a:ln>
             <a:noFill/>
@@ -4375,20 +3785,88 @@
       </p:sp>
       <p:sp>
         <p:nvSpPr>
-          <p:cNvPr id="4" name="Rectangle 3"/>
-          <p:cNvSpPr/>
-          <p:nvPr/>
-        </p:nvSpPr>
-        <p:spPr>
-          <a:xfrm>
-            <a:off x="0" y="6748272"/>
-            <a:ext cx="12188952" cy="109728"/>
+          <p:cNvPr id="4" name="TextBox 3"/>
+          <p:cNvSpPr txBox="1"/>
+          <p:nvPr/>
+        </p:nvSpPr>
+        <p:spPr>
+          <a:xfrm>
+            <a:off x="320040" y="292608"/>
+            <a:ext cx="9144000" cy="384048"/>
           </a:xfrm>
           <a:prstGeom prst="rect">
             <a:avLst/>
           </a:prstGeom>
+          <a:noFill/>
+        </p:spPr>
+        <p:txBody>
+          <a:bodyPr wrap="square">
+            <a:spAutoFit/>
+          </a:bodyPr>
+          <a:lstStyle/>
+          <a:p>
+            <a:pPr algn="l"/>
+            <a:r>
+              <a:rPr sz="1100" b="1" i="0">
+                <a:solidFill>
+                  <a:srgbClr val="4A9E9E"/>
+                </a:solidFill>
+              </a:rPr>
+              <a:t>FICHE TECHNIQUE</a:t>
+            </a:r>
+          </a:p>
+        </p:txBody>
+      </p:sp>
+      <p:sp>
+        <p:nvSpPr>
+          <p:cNvPr id="5" name="TextBox 4"/>
+          <p:cNvSpPr txBox="1"/>
+          <p:nvPr/>
+        </p:nvSpPr>
+        <p:spPr>
+          <a:xfrm>
+            <a:off x="320040" y="621792"/>
+            <a:ext cx="7315200" cy="548640"/>
+          </a:xfrm>
+          <a:prstGeom prst="rect">
+            <a:avLst/>
+          </a:prstGeom>
+          <a:noFill/>
+        </p:spPr>
+        <p:txBody>
+          <a:bodyPr wrap="square">
+            <a:spAutoFit/>
+          </a:bodyPr>
+          <a:lstStyle/>
+          <a:p>
+            <a:pPr algn="l"/>
+            <a:r>
+              <a:rPr sz="2800" b="1" i="0">
+                <a:solidFill>
+                  <a:srgbClr val="2D2D2D"/>
+                </a:solidFill>
+              </a:rPr>
+              <a:t>Château Gonflable Pirate</a:t>
+            </a:r>
+          </a:p>
+        </p:txBody>
+      </p:sp>
+      <p:sp>
+        <p:nvSpPr>
+          <p:cNvPr id="6" name="Rectangle 5"/>
+          <p:cNvSpPr/>
+          <p:nvPr/>
+        </p:nvSpPr>
+        <p:spPr>
+          <a:xfrm>
+            <a:off x="320040" y="1234440"/>
+            <a:ext cx="11521440" cy="27432"/>
+          </a:xfrm>
+          <a:prstGeom prst="rect">
+            <a:avLst/>
+          </a:prstGeom>
           <a:solidFill>
-            <a:srgbClr val="F5C518"/>
+            <a:srgbClr val="EEECE9"/>
           </a:solidFill>
           <a:ln>
             <a:noFill/>
@@ -4418,20 +3896,22 @@
       </p:sp>
       <p:sp>
         <p:nvSpPr>
-          <p:cNvPr id="5" name="Rectangle 4"/>
+          <p:cNvPr id="7" name="Rounded Rectangle 6"/>
           <p:cNvSpPr/>
           <p:nvPr/>
         </p:nvSpPr>
         <p:spPr>
           <a:xfrm>
-            <a:off x="0" y="109728"/>
-            <a:ext cx="73152" cy="6638544"/>
-          </a:xfrm>
-          <a:prstGeom prst="rect">
-            <a:avLst/>
+            <a:off x="320040" y="1417320"/>
+            <a:ext cx="5394960" cy="5120640"/>
+          </a:xfrm>
+          <a:prstGeom prst="roundRect">
+            <a:avLst>
+              <a:gd name="adj" fmla="val 4000"/>
+            </a:avLst>
           </a:prstGeom>
           <a:solidFill>
-            <a:srgbClr val="B88A00"/>
+            <a:srgbClr val="FFFFFF"/>
           </a:solidFill>
           <a:ln>
             <a:noFill/>
@@ -4461,20 +3941,54 @@
       </p:sp>
       <p:sp>
         <p:nvSpPr>
-          <p:cNvPr id="6" name="Rectangle 5"/>
-          <p:cNvSpPr/>
-          <p:nvPr/>
-        </p:nvSpPr>
-        <p:spPr>
-          <a:xfrm>
-            <a:off x="73152" y="109728"/>
-            <a:ext cx="12115800" cy="960120"/>
+          <p:cNvPr id="8" name="TextBox 7"/>
+          <p:cNvSpPr txBox="1"/>
+          <p:nvPr/>
+        </p:nvSpPr>
+        <p:spPr>
+          <a:xfrm>
+            <a:off x="594360" y="1600200"/>
+            <a:ext cx="4846320" cy="365760"/>
           </a:xfrm>
           <a:prstGeom prst="rect">
             <a:avLst/>
           </a:prstGeom>
+          <a:noFill/>
+        </p:spPr>
+        <p:txBody>
+          <a:bodyPr wrap="square">
+            <a:spAutoFit/>
+          </a:bodyPr>
+          <a:lstStyle/>
+          <a:p>
+            <a:pPr algn="l"/>
+            <a:r>
+              <a:rPr sz="1300" b="1" i="0">
+                <a:solidFill>
+                  <a:srgbClr val="2D2D2D"/>
+                </a:solidFill>
+              </a:rPr>
+              <a:t>Caractéristiques</a:t>
+            </a:r>
+          </a:p>
+        </p:txBody>
+      </p:sp>
+      <p:sp>
+        <p:nvSpPr>
+          <p:cNvPr id="9" name="Rectangle 8"/>
+          <p:cNvSpPr/>
+          <p:nvPr/>
+        </p:nvSpPr>
+        <p:spPr>
+          <a:xfrm>
+            <a:off x="594360" y="1993392"/>
+            <a:ext cx="4846320" cy="22860"/>
+          </a:xfrm>
+          <a:prstGeom prst="rect">
+            <a:avLst/>
+          </a:prstGeom>
           <a:solidFill>
-            <a:srgbClr val="0E2755"/>
+            <a:srgbClr val="EEECE9"/>
           </a:solidFill>
           <a:ln>
             <a:noFill/>
@@ -4504,90 +4018,22 @@
       </p:sp>
       <p:sp>
         <p:nvSpPr>
-          <p:cNvPr id="7" name="TextBox 6"/>
-          <p:cNvSpPr txBox="1"/>
-          <p:nvPr/>
-        </p:nvSpPr>
-        <p:spPr>
-          <a:xfrm>
-            <a:off x="274320" y="164592"/>
-            <a:ext cx="8229600" cy="822960"/>
-          </a:xfrm>
-          <a:prstGeom prst="rect">
-            <a:avLst/>
-          </a:prstGeom>
-          <a:noFill/>
-        </p:spPr>
-        <p:txBody>
-          <a:bodyPr wrap="square">
-            <a:spAutoFit/>
-          </a:bodyPr>
-          <a:lstStyle/>
-          <a:p>
-            <a:pPr algn="l"/>
-            <a:r>
-              <a:rPr sz="3000" b="1" i="0">
-                <a:solidFill>
-                  <a:srgbClr val="F5C518"/>
-                </a:solidFill>
-              </a:rPr>
-              <a:t>Fiche Technique — Château Gonflable Pirate</a:t>
-            </a:r>
-          </a:p>
-        </p:txBody>
-      </p:sp>
-      <p:sp>
-        <p:nvSpPr>
-          <p:cNvPr id="8" name="TextBox 7"/>
-          <p:cNvSpPr txBox="1"/>
-          <p:nvPr/>
-        </p:nvSpPr>
-        <p:spPr>
-          <a:xfrm>
-            <a:off x="9144000" y="292608"/>
-            <a:ext cx="2743200" cy="502920"/>
-          </a:xfrm>
-          <a:prstGeom prst="rect">
-            <a:avLst/>
-          </a:prstGeom>
-          <a:noFill/>
-        </p:spPr>
-        <p:txBody>
-          <a:bodyPr wrap="square">
-            <a:spAutoFit/>
-          </a:bodyPr>
-          <a:lstStyle/>
-          <a:p>
-            <a:pPr algn="r"/>
-            <a:r>
-              <a:rPr sz="2200" b="1" i="0">
-                <a:solidFill>
-                  <a:srgbClr val="CC1F1F"/>
-                </a:solidFill>
-              </a:rPr>
-              <a:t>1 700,00 € HT</a:t>
-            </a:r>
-          </a:p>
-        </p:txBody>
-      </p:sp>
-      <p:sp>
-        <p:nvSpPr>
-          <p:cNvPr id="9" name="Rounded Rectangle 8"/>
+          <p:cNvPr id="10" name="Rounded Rectangle 9"/>
           <p:cNvSpPr/>
           <p:nvPr/>
         </p:nvSpPr>
         <p:spPr>
           <a:xfrm>
-            <a:off x="274320" y="1234440"/>
-            <a:ext cx="5486400" cy="5257800"/>
+            <a:off x="338328" y="2084831"/>
+            <a:ext cx="5358384" cy="658368"/>
           </a:xfrm>
           <a:prstGeom prst="roundRect">
             <a:avLst>
-              <a:gd name="adj" fmla="val 5000"/>
+              <a:gd name="adj" fmla="val 2000"/>
             </a:avLst>
           </a:prstGeom>
           <a:solidFill>
-            <a:srgbClr val="0D2452"/>
+            <a:srgbClr val="F2EEE8"/>
           </a:solidFill>
           <a:ln>
             <a:noFill/>
@@ -4617,14 +4063,14 @@
       </p:sp>
       <p:sp>
         <p:nvSpPr>
-          <p:cNvPr id="10" name="TextBox 9"/>
+          <p:cNvPr id="11" name="TextBox 10"/>
           <p:cNvSpPr txBox="1"/>
           <p:nvPr/>
         </p:nvSpPr>
         <p:spPr>
           <a:xfrm>
-            <a:off x="411480" y="1298448"/>
-            <a:ext cx="5212080" cy="457200"/>
+            <a:off x="594360" y="2157984"/>
+            <a:ext cx="1645920" cy="274320"/>
           </a:xfrm>
           <a:prstGeom prst="rect">
             <a:avLst/>
@@ -4639,32 +4085,136 @@
           <a:p>
             <a:pPr algn="l"/>
             <a:r>
-              <a:rPr sz="1600" b="1" i="0">
+              <a:rPr sz="1000" b="1" i="0">
                 <a:solidFill>
-                  <a:srgbClr val="F5C518"/>
+                  <a:srgbClr val="7A7A7A"/>
                 </a:solidFill>
               </a:rPr>
-              <a:t>Caractéristiques techniques</a:t>
-            </a:r>
-          </a:p>
-        </p:txBody>
-      </p:sp>
-      <p:sp>
-        <p:nvSpPr>
-          <p:cNvPr id="11" name="Rectangle 10"/>
-          <p:cNvSpPr/>
-          <p:nvPr/>
-        </p:nvSpPr>
-        <p:spPr>
-          <a:xfrm>
-            <a:off x="292608" y="1783080"/>
-            <a:ext cx="5449824" cy="749808"/>
+              <a:t>Dimensions</a:t>
+            </a:r>
+          </a:p>
+        </p:txBody>
+      </p:sp>
+      <p:sp>
+        <p:nvSpPr>
+          <p:cNvPr id="12" name="TextBox 11"/>
+          <p:cNvSpPr txBox="1"/>
+          <p:nvPr/>
+        </p:nvSpPr>
+        <p:spPr>
+          <a:xfrm>
+            <a:off x="594360" y="2404872"/>
+            <a:ext cx="4846320" cy="274320"/>
           </a:xfrm>
           <a:prstGeom prst="rect">
             <a:avLst/>
           </a:prstGeom>
+          <a:noFill/>
+        </p:spPr>
+        <p:txBody>
+          <a:bodyPr wrap="square">
+            <a:spAutoFit/>
+          </a:bodyPr>
+          <a:lstStyle/>
+          <a:p>
+            <a:pPr algn="l"/>
+            <a:r>
+              <a:rPr sz="1200" b="0" i="0">
+                <a:solidFill>
+                  <a:srgbClr val="2D2D2D"/>
+                </a:solidFill>
+              </a:rPr>
+              <a:t>L 8 m × P 5,1 m × H 4,3 m</a:t>
+            </a:r>
+          </a:p>
+        </p:txBody>
+      </p:sp>
+      <p:sp>
+        <p:nvSpPr>
+          <p:cNvPr id="13" name="TextBox 12"/>
+          <p:cNvSpPr txBox="1"/>
+          <p:nvPr/>
+        </p:nvSpPr>
+        <p:spPr>
+          <a:xfrm>
+            <a:off x="594360" y="2871215"/>
+            <a:ext cx="1645920" cy="274320"/>
+          </a:xfrm>
+          <a:prstGeom prst="rect">
+            <a:avLst/>
+          </a:prstGeom>
+          <a:noFill/>
+        </p:spPr>
+        <p:txBody>
+          <a:bodyPr wrap="square">
+            <a:spAutoFit/>
+          </a:bodyPr>
+          <a:lstStyle/>
+          <a:p>
+            <a:pPr algn="l"/>
+            <a:r>
+              <a:rPr sz="1000" b="1" i="0">
+                <a:solidFill>
+                  <a:srgbClr val="7A7A7A"/>
+                </a:solidFill>
+              </a:rPr>
+              <a:t>Alimentation</a:t>
+            </a:r>
+          </a:p>
+        </p:txBody>
+      </p:sp>
+      <p:sp>
+        <p:nvSpPr>
+          <p:cNvPr id="14" name="TextBox 13"/>
+          <p:cNvSpPr txBox="1"/>
+          <p:nvPr/>
+        </p:nvSpPr>
+        <p:spPr>
+          <a:xfrm>
+            <a:off x="594360" y="3118103"/>
+            <a:ext cx="4846320" cy="274320"/>
+          </a:xfrm>
+          <a:prstGeom prst="rect">
+            <a:avLst/>
+          </a:prstGeom>
+          <a:noFill/>
+        </p:spPr>
+        <p:txBody>
+          <a:bodyPr wrap="square">
+            <a:spAutoFit/>
+          </a:bodyPr>
+          <a:lstStyle/>
+          <a:p>
+            <a:pPr algn="l"/>
+            <a:r>
+              <a:rPr sz="1200" b="0" i="0">
+                <a:solidFill>
+                  <a:srgbClr val="2D2D2D"/>
+                </a:solidFill>
+              </a:rPr>
+              <a:t>220 V / 16 A — prise standard</a:t>
+            </a:r>
+          </a:p>
+        </p:txBody>
+      </p:sp>
+      <p:sp>
+        <p:nvSpPr>
+          <p:cNvPr id="15" name="Rounded Rectangle 14"/>
+          <p:cNvSpPr/>
+          <p:nvPr/>
+        </p:nvSpPr>
+        <p:spPr>
+          <a:xfrm>
+            <a:off x="338328" y="3511296"/>
+            <a:ext cx="5358384" cy="658368"/>
+          </a:xfrm>
+          <a:prstGeom prst="roundRect">
+            <a:avLst>
+              <a:gd name="adj" fmla="val 2000"/>
+            </a:avLst>
+          </a:prstGeom>
           <a:solidFill>
-            <a:srgbClr val="122C5E"/>
+            <a:srgbClr val="F2EEE8"/>
           </a:solidFill>
           <a:ln>
             <a:noFill/>
@@ -4694,14 +4244,14 @@
       </p:sp>
       <p:sp>
         <p:nvSpPr>
-          <p:cNvPr id="12" name="TextBox 11"/>
+          <p:cNvPr id="16" name="TextBox 15"/>
           <p:cNvSpPr txBox="1"/>
           <p:nvPr/>
         </p:nvSpPr>
         <p:spPr>
           <a:xfrm>
-            <a:off x="411480" y="1828800"/>
-            <a:ext cx="1554480" cy="347472"/>
+            <a:off x="594360" y="3584448"/>
+            <a:ext cx="1645920" cy="274320"/>
           </a:xfrm>
           <a:prstGeom prst="rect">
             <a:avLst/>
@@ -4716,26 +4266,26 @@
           <a:p>
             <a:pPr algn="l"/>
             <a:r>
-              <a:rPr sz="1200" b="1" i="0">
+              <a:rPr sz="1000" b="1" i="0">
                 <a:solidFill>
-                  <a:srgbClr val="F5C518"/>
+                  <a:srgbClr val="7A7A7A"/>
                 </a:solidFill>
               </a:rPr>
-              <a:t>Dimensions</a:t>
-            </a:r>
-          </a:p>
-        </p:txBody>
-      </p:sp>
-      <p:sp>
-        <p:nvSpPr>
-          <p:cNvPr id="13" name="TextBox 12"/>
+              <a:t>Capacité max</a:t>
+            </a:r>
+          </a:p>
+        </p:txBody>
+      </p:sp>
+      <p:sp>
+        <p:nvSpPr>
+          <p:cNvPr id="17" name="TextBox 16"/>
           <p:cNvSpPr txBox="1"/>
           <p:nvPr/>
         </p:nvSpPr>
         <p:spPr>
           <a:xfrm>
-            <a:off x="411480" y="2130552"/>
-            <a:ext cx="5212080" cy="347472"/>
+            <a:off x="594360" y="3831335"/>
+            <a:ext cx="4846320" cy="274320"/>
           </a:xfrm>
           <a:prstGeom prst="rect">
             <a:avLst/>
@@ -4752,30 +4302,100 @@
             <a:r>
               <a:rPr sz="1200" b="0" i="0">
                 <a:solidFill>
-                  <a:srgbClr val="FFFFFF"/>
+                  <a:srgbClr val="2D2D2D"/>
                 </a:solidFill>
               </a:rPr>
-              <a:t>L 8 m × Profondeur 5,1 m × Hauteur 4,3 m</a:t>
-            </a:r>
-          </a:p>
-        </p:txBody>
-      </p:sp>
-      <p:sp>
-        <p:nvSpPr>
-          <p:cNvPr id="14" name="Rectangle 13"/>
-          <p:cNvSpPr/>
-          <p:nvPr/>
-        </p:nvSpPr>
-        <p:spPr>
-          <a:xfrm>
-            <a:off x="292608" y="2587752"/>
-            <a:ext cx="5449824" cy="749808"/>
+              <a:t>12 enfants  ou  6 adultes</a:t>
+            </a:r>
+          </a:p>
+        </p:txBody>
+      </p:sp>
+      <p:sp>
+        <p:nvSpPr>
+          <p:cNvPr id="18" name="TextBox 17"/>
+          <p:cNvSpPr txBox="1"/>
+          <p:nvPr/>
+        </p:nvSpPr>
+        <p:spPr>
+          <a:xfrm>
+            <a:off x="594360" y="4297679"/>
+            <a:ext cx="1645920" cy="274320"/>
           </a:xfrm>
           <a:prstGeom prst="rect">
             <a:avLst/>
           </a:prstGeom>
+          <a:noFill/>
+        </p:spPr>
+        <p:txBody>
+          <a:bodyPr wrap="square">
+            <a:spAutoFit/>
+          </a:bodyPr>
+          <a:lstStyle/>
+          <a:p>
+            <a:pPr algn="l"/>
+            <a:r>
+              <a:rPr sz="1000" b="1" i="0">
+                <a:solidFill>
+                  <a:srgbClr val="7A7A7A"/>
+                </a:solidFill>
+              </a:rPr>
+              <a:t>Certification</a:t>
+            </a:r>
+          </a:p>
+        </p:txBody>
+      </p:sp>
+      <p:sp>
+        <p:nvSpPr>
+          <p:cNvPr id="19" name="TextBox 18"/>
+          <p:cNvSpPr txBox="1"/>
+          <p:nvPr/>
+        </p:nvSpPr>
+        <p:spPr>
+          <a:xfrm>
+            <a:off x="594360" y="4544567"/>
+            <a:ext cx="4846320" cy="274320"/>
+          </a:xfrm>
+          <a:prstGeom prst="rect">
+            <a:avLst/>
+          </a:prstGeom>
+          <a:noFill/>
+        </p:spPr>
+        <p:txBody>
+          <a:bodyPr wrap="square">
+            <a:spAutoFit/>
+          </a:bodyPr>
+          <a:lstStyle/>
+          <a:p>
+            <a:pPr algn="l"/>
+            <a:r>
+              <a:rPr sz="1200" b="0" i="0">
+                <a:solidFill>
+                  <a:srgbClr val="2D2D2D"/>
+                </a:solidFill>
+              </a:rPr>
+              <a:t>Conforme EN 14960</a:t>
+            </a:r>
+          </a:p>
+        </p:txBody>
+      </p:sp>
+      <p:sp>
+        <p:nvSpPr>
+          <p:cNvPr id="20" name="Rounded Rectangle 19"/>
+          <p:cNvSpPr/>
+          <p:nvPr/>
+        </p:nvSpPr>
+        <p:spPr>
+          <a:xfrm>
+            <a:off x="338328" y="4937760"/>
+            <a:ext cx="5358384" cy="658368"/>
+          </a:xfrm>
+          <a:prstGeom prst="roundRect">
+            <a:avLst>
+              <a:gd name="adj" fmla="val 2000"/>
+            </a:avLst>
+          </a:prstGeom>
           <a:solidFill>
-            <a:srgbClr val="0D224A"/>
+            <a:srgbClr val="F2EEE8"/>
           </a:solidFill>
           <a:ln>
             <a:noFill/>
@@ -4805,14 +4425,14 @@
       </p:sp>
       <p:sp>
         <p:nvSpPr>
-          <p:cNvPr id="15" name="TextBox 14"/>
+          <p:cNvPr id="21" name="TextBox 20"/>
           <p:cNvSpPr txBox="1"/>
           <p:nvPr/>
         </p:nvSpPr>
         <p:spPr>
           <a:xfrm>
-            <a:off x="411480" y="2633472"/>
-            <a:ext cx="1554480" cy="347472"/>
+            <a:off x="594360" y="5010912"/>
+            <a:ext cx="1645920" cy="274320"/>
           </a:xfrm>
           <a:prstGeom prst="rect">
             <a:avLst/>
@@ -4827,26 +4447,26 @@
           <a:p>
             <a:pPr algn="l"/>
             <a:r>
-              <a:rPr sz="1200" b="1" i="0">
+              <a:rPr sz="1000" b="1" i="0">
                 <a:solidFill>
-                  <a:srgbClr val="F5C518"/>
+                  <a:srgbClr val="7A7A7A"/>
                 </a:solidFill>
               </a:rPr>
-              <a:t>Alimentation</a:t>
-            </a:r>
-          </a:p>
-        </p:txBody>
-      </p:sp>
-      <p:sp>
-        <p:nvSpPr>
-          <p:cNvPr id="16" name="TextBox 15"/>
+              <a:t>État</a:t>
+            </a:r>
+          </a:p>
+        </p:txBody>
+      </p:sp>
+      <p:sp>
+        <p:nvSpPr>
+          <p:cNvPr id="22" name="TextBox 21"/>
           <p:cNvSpPr txBox="1"/>
           <p:nvPr/>
         </p:nvSpPr>
         <p:spPr>
           <a:xfrm>
-            <a:off x="411480" y="2935224"/>
-            <a:ext cx="5212080" cy="347472"/>
+            <a:off x="594360" y="5257800"/>
+            <a:ext cx="4846320" cy="274320"/>
           </a:xfrm>
           <a:prstGeom prst="rect">
             <a:avLst/>
@@ -4863,30 +4483,100 @@
             <a:r>
               <a:rPr sz="1200" b="0" i="0">
                 <a:solidFill>
-                  <a:srgbClr val="FFFFFF"/>
+                  <a:srgbClr val="2D2D2D"/>
                 </a:solidFill>
               </a:rPr>
-              <a:t>1 prise 220 V / 16 A (standard)</a:t>
-            </a:r>
-          </a:p>
-        </p:txBody>
-      </p:sp>
-      <p:sp>
-        <p:nvSpPr>
-          <p:cNvPr id="17" name="Rectangle 16"/>
-          <p:cNvSpPr/>
-          <p:nvPr/>
-        </p:nvSpPr>
-        <p:spPr>
-          <a:xfrm>
-            <a:off x="292608" y="3392424"/>
-            <a:ext cx="5449824" cy="749808"/>
+              <a:t>Occasion — bon état général</a:t>
+            </a:r>
+          </a:p>
+        </p:txBody>
+      </p:sp>
+      <p:sp>
+        <p:nvSpPr>
+          <p:cNvPr id="23" name="TextBox 22"/>
+          <p:cNvSpPr txBox="1"/>
+          <p:nvPr/>
+        </p:nvSpPr>
+        <p:spPr>
+          <a:xfrm>
+            <a:off x="594360" y="5724144"/>
+            <a:ext cx="1645920" cy="274320"/>
           </a:xfrm>
           <a:prstGeom prst="rect">
             <a:avLst/>
           </a:prstGeom>
+          <a:noFill/>
+        </p:spPr>
+        <p:txBody>
+          <a:bodyPr wrap="square">
+            <a:spAutoFit/>
+          </a:bodyPr>
+          <a:lstStyle/>
+          <a:p>
+            <a:pPr algn="l"/>
+            <a:r>
+              <a:rPr sz="1000" b="1" i="0">
+                <a:solidFill>
+                  <a:srgbClr val="7A7A7A"/>
+                </a:solidFill>
+              </a:rPr>
+              <a:t>Livraison</a:t>
+            </a:r>
+          </a:p>
+        </p:txBody>
+      </p:sp>
+      <p:sp>
+        <p:nvSpPr>
+          <p:cNvPr id="24" name="TextBox 23"/>
+          <p:cNvSpPr txBox="1"/>
+          <p:nvPr/>
+        </p:nvSpPr>
+        <p:spPr>
+          <a:xfrm>
+            <a:off x="594360" y="5971031"/>
+            <a:ext cx="4846320" cy="274320"/>
+          </a:xfrm>
+          <a:prstGeom prst="rect">
+            <a:avLst/>
+          </a:prstGeom>
+          <a:noFill/>
+        </p:spPr>
+        <p:txBody>
+          <a:bodyPr wrap="square">
+            <a:spAutoFit/>
+          </a:bodyPr>
+          <a:lstStyle/>
+          <a:p>
+            <a:pPr algn="l"/>
+            <a:r>
+              <a:rPr sz="1200" b="0" i="0">
+                <a:solidFill>
+                  <a:srgbClr val="2D2D2D"/>
+                </a:solidFill>
+              </a:rPr>
+              <a:t>À définir selon localisation</a:t>
+            </a:r>
+          </a:p>
+        </p:txBody>
+      </p:sp>
+      <p:sp>
+        <p:nvSpPr>
+          <p:cNvPr id="25" name="Rounded Rectangle 24"/>
+          <p:cNvSpPr/>
+          <p:nvPr/>
+        </p:nvSpPr>
+        <p:spPr>
+          <a:xfrm>
+            <a:off x="6080760" y="1417320"/>
+            <a:ext cx="5788152" cy="5120640"/>
+          </a:xfrm>
+          <a:prstGeom prst="roundRect">
+            <a:avLst>
+              <a:gd name="adj" fmla="val 4000"/>
+            </a:avLst>
+          </a:prstGeom>
           <a:solidFill>
-            <a:srgbClr val="122C5E"/>
+            <a:srgbClr val="FFFFFF"/>
           </a:solidFill>
           <a:ln>
             <a:noFill/>
@@ -4916,14 +4606,14 @@
       </p:sp>
       <p:sp>
         <p:nvSpPr>
-          <p:cNvPr id="18" name="TextBox 17"/>
+          <p:cNvPr id="26" name="TextBox 25"/>
           <p:cNvSpPr txBox="1"/>
           <p:nvPr/>
         </p:nvSpPr>
         <p:spPr>
           <a:xfrm>
-            <a:off x="411480" y="3438144"/>
-            <a:ext cx="1554480" cy="347472"/>
+            <a:off x="6355080" y="1600200"/>
+            <a:ext cx="5212080" cy="365760"/>
           </a:xfrm>
           <a:prstGeom prst="rect">
             <a:avLst/>
@@ -4938,66 +4628,32 @@
           <a:p>
             <a:pPr algn="l"/>
             <a:r>
-              <a:rPr sz="1200" b="1" i="0">
+              <a:rPr sz="1300" b="1" i="0">
                 <a:solidFill>
-                  <a:srgbClr val="F5C518"/>
+                  <a:srgbClr val="2D2D2D"/>
                 </a:solidFill>
               </a:rPr>
-              <a:t>Capacité</a:t>
-            </a:r>
-          </a:p>
-        </p:txBody>
-      </p:sp>
-      <p:sp>
-        <p:nvSpPr>
-          <p:cNvPr id="19" name="TextBox 18"/>
-          <p:cNvSpPr txBox="1"/>
-          <p:nvPr/>
-        </p:nvSpPr>
-        <p:spPr>
-          <a:xfrm>
-            <a:off x="411480" y="3739896"/>
-            <a:ext cx="5212080" cy="347472"/>
+              <a:t>Points forts</a:t>
+            </a:r>
+          </a:p>
+        </p:txBody>
+      </p:sp>
+      <p:sp>
+        <p:nvSpPr>
+          <p:cNvPr id="27" name="Rectangle 26"/>
+          <p:cNvSpPr/>
+          <p:nvPr/>
+        </p:nvSpPr>
+        <p:spPr>
+          <a:xfrm>
+            <a:off x="6355080" y="1993392"/>
+            <a:ext cx="5212080" cy="22860"/>
           </a:xfrm>
           <a:prstGeom prst="rect">
             <a:avLst/>
           </a:prstGeom>
-          <a:noFill/>
-        </p:spPr>
-        <p:txBody>
-          <a:bodyPr wrap="square">
-            <a:spAutoFit/>
-          </a:bodyPr>
-          <a:lstStyle/>
-          <a:p>
-            <a:pPr algn="l"/>
-            <a:r>
-              <a:rPr sz="1200" b="0" i="0">
-                <a:solidFill>
-                  <a:srgbClr val="FFFFFF"/>
-                </a:solidFill>
-              </a:rPr>
-              <a:t>12 enfants  OU  6 adultes</a:t>
-            </a:r>
-          </a:p>
-        </p:txBody>
-      </p:sp>
-      <p:sp>
-        <p:nvSpPr>
-          <p:cNvPr id="20" name="Rectangle 19"/>
-          <p:cNvSpPr/>
-          <p:nvPr/>
-        </p:nvSpPr>
-        <p:spPr>
-          <a:xfrm>
-            <a:off x="292608" y="4197096"/>
-            <a:ext cx="5449824" cy="749808"/>
-          </a:xfrm>
-          <a:prstGeom prst="rect">
-            <a:avLst/>
-          </a:prstGeom>
           <a:solidFill>
-            <a:srgbClr val="0D224A"/>
+            <a:srgbClr val="EEECE9"/>
           </a:solidFill>
           <a:ln>
             <a:noFill/>
@@ -5027,88 +4683,22 @@
       </p:sp>
       <p:sp>
         <p:nvSpPr>
-          <p:cNvPr id="21" name="TextBox 20"/>
-          <p:cNvSpPr txBox="1"/>
-          <p:nvPr/>
-        </p:nvSpPr>
-        <p:spPr>
-          <a:xfrm>
-            <a:off x="411480" y="4242816"/>
-            <a:ext cx="1554480" cy="347472"/>
-          </a:xfrm>
-          <a:prstGeom prst="rect">
-            <a:avLst/>
-          </a:prstGeom>
-          <a:noFill/>
-        </p:spPr>
-        <p:txBody>
-          <a:bodyPr wrap="square">
-            <a:spAutoFit/>
-          </a:bodyPr>
-          <a:lstStyle/>
-          <a:p>
-            <a:pPr algn="l"/>
-            <a:r>
-              <a:rPr sz="1200" b="1" i="0">
-                <a:solidFill>
-                  <a:srgbClr val="F5C518"/>
-                </a:solidFill>
-              </a:rPr>
-              <a:t>Certification</a:t>
-            </a:r>
-          </a:p>
-        </p:txBody>
-      </p:sp>
-      <p:sp>
-        <p:nvSpPr>
-          <p:cNvPr id="22" name="TextBox 21"/>
-          <p:cNvSpPr txBox="1"/>
-          <p:nvPr/>
-        </p:nvSpPr>
-        <p:spPr>
-          <a:xfrm>
-            <a:off x="411480" y="4544568"/>
-            <a:ext cx="5212080" cy="347472"/>
-          </a:xfrm>
-          <a:prstGeom prst="rect">
-            <a:avLst/>
-          </a:prstGeom>
-          <a:noFill/>
-        </p:spPr>
-        <p:txBody>
-          <a:bodyPr wrap="square">
-            <a:spAutoFit/>
-          </a:bodyPr>
-          <a:lstStyle/>
-          <a:p>
-            <a:pPr algn="l"/>
-            <a:r>
-              <a:rPr sz="1200" b="0" i="0">
-                <a:solidFill>
-                  <a:srgbClr val="FFFFFF"/>
-                </a:solidFill>
-              </a:rPr>
-              <a:t>Conforme EN 14960</a:t>
-            </a:r>
-          </a:p>
-        </p:txBody>
-      </p:sp>
-      <p:sp>
-        <p:nvSpPr>
-          <p:cNvPr id="23" name="Rectangle 22"/>
+          <p:cNvPr id="28" name="Rounded Rectangle 27"/>
           <p:cNvSpPr/>
           <p:nvPr/>
         </p:nvSpPr>
         <p:spPr>
           <a:xfrm>
-            <a:off x="292608" y="5001768"/>
-            <a:ext cx="5449824" cy="749808"/>
-          </a:xfrm>
-          <a:prstGeom prst="rect">
-            <a:avLst/>
+            <a:off x="6099048" y="2084831"/>
+            <a:ext cx="5751576" cy="1078992"/>
+          </a:xfrm>
+          <a:prstGeom prst="roundRect">
+            <a:avLst>
+              <a:gd name="adj" fmla="val 4000"/>
+            </a:avLst>
           </a:prstGeom>
           <a:solidFill>
-            <a:srgbClr val="122C5E"/>
+            <a:srgbClr val="D6EDED"/>
           </a:solidFill>
           <a:ln>
             <a:noFill/>
@@ -5138,88 +4728,22 @@
       </p:sp>
       <p:sp>
         <p:nvSpPr>
-          <p:cNvPr id="24" name="TextBox 23"/>
-          <p:cNvSpPr txBox="1"/>
-          <p:nvPr/>
-        </p:nvSpPr>
-        <p:spPr>
-          <a:xfrm>
-            <a:off x="411480" y="5047488"/>
-            <a:ext cx="1554480" cy="347472"/>
-          </a:xfrm>
-          <a:prstGeom prst="rect">
-            <a:avLst/>
-          </a:prstGeom>
-          <a:noFill/>
-        </p:spPr>
-        <p:txBody>
-          <a:bodyPr wrap="square">
-            <a:spAutoFit/>
-          </a:bodyPr>
-          <a:lstStyle/>
-          <a:p>
-            <a:pPr algn="l"/>
-            <a:r>
-              <a:rPr sz="1200" b="1" i="0">
-                <a:solidFill>
-                  <a:srgbClr val="F5C518"/>
-                </a:solidFill>
-              </a:rPr>
-              <a:t>État</a:t>
-            </a:r>
-          </a:p>
-        </p:txBody>
-      </p:sp>
-      <p:sp>
-        <p:nvSpPr>
-          <p:cNvPr id="25" name="TextBox 24"/>
-          <p:cNvSpPr txBox="1"/>
-          <p:nvPr/>
-        </p:nvSpPr>
-        <p:spPr>
-          <a:xfrm>
-            <a:off x="411480" y="5349240"/>
-            <a:ext cx="5212080" cy="347472"/>
-          </a:xfrm>
-          <a:prstGeom prst="rect">
-            <a:avLst/>
-          </a:prstGeom>
-          <a:noFill/>
-        </p:spPr>
-        <p:txBody>
-          <a:bodyPr wrap="square">
-            <a:spAutoFit/>
-          </a:bodyPr>
-          <a:lstStyle/>
-          <a:p>
-            <a:pPr algn="l"/>
-            <a:r>
-              <a:rPr sz="1200" b="0" i="0">
-                <a:solidFill>
-                  <a:srgbClr val="FFFFFF"/>
-                </a:solidFill>
-              </a:rPr>
-              <a:t>Occasion — bon état général</a:t>
-            </a:r>
-          </a:p>
-        </p:txBody>
-      </p:sp>
-      <p:sp>
-        <p:nvSpPr>
-          <p:cNvPr id="26" name="Rectangle 25"/>
+          <p:cNvPr id="29" name="Rounded Rectangle 28"/>
           <p:cNvSpPr/>
           <p:nvPr/>
         </p:nvSpPr>
         <p:spPr>
           <a:xfrm>
-            <a:off x="292608" y="5806440"/>
-            <a:ext cx="5449824" cy="749808"/>
-          </a:xfrm>
-          <a:prstGeom prst="rect">
-            <a:avLst/>
+            <a:off x="6263640" y="2377439"/>
+            <a:ext cx="164592" cy="164592"/>
+          </a:xfrm>
+          <a:prstGeom prst="roundRect">
+            <a:avLst>
+              <a:gd name="adj" fmla="val 50000"/>
+            </a:avLst>
           </a:prstGeom>
           <a:solidFill>
-            <a:srgbClr val="0D224A"/>
+            <a:srgbClr val="4A9E9E"/>
           </a:solidFill>
           <a:ln>
             <a:noFill/>
@@ -5249,14 +4773,14 @@
       </p:sp>
       <p:sp>
         <p:nvSpPr>
-          <p:cNvPr id="27" name="TextBox 26"/>
+          <p:cNvPr id="30" name="TextBox 29"/>
           <p:cNvSpPr txBox="1"/>
           <p:nvPr/>
         </p:nvSpPr>
         <p:spPr>
           <a:xfrm>
-            <a:off x="411480" y="5852160"/>
-            <a:ext cx="1554480" cy="347472"/>
+            <a:off x="6537960" y="2176272"/>
+            <a:ext cx="5120640" cy="347472"/>
           </a:xfrm>
           <a:prstGeom prst="rect">
             <a:avLst/>
@@ -5271,26 +4795,26 @@
           <a:p>
             <a:pPr algn="l"/>
             <a:r>
-              <a:rPr sz="1200" b="1" i="0">
+              <a:rPr sz="1300" b="1" i="0">
                 <a:solidFill>
-                  <a:srgbClr val="F5C518"/>
+                  <a:srgbClr val="2D2D2D"/>
                 </a:solidFill>
               </a:rPr>
-              <a:t>Livraison</a:t>
-            </a:r>
-          </a:p>
-        </p:txBody>
-      </p:sp>
-      <p:sp>
-        <p:nvSpPr>
-          <p:cNvPr id="28" name="TextBox 27"/>
+              <a:t>Thème immersif</a:t>
+            </a:r>
+          </a:p>
+        </p:txBody>
+      </p:sp>
+      <p:sp>
+        <p:nvSpPr>
+          <p:cNvPr id="31" name="TextBox 30"/>
           <p:cNvSpPr txBox="1"/>
           <p:nvPr/>
         </p:nvSpPr>
         <p:spPr>
           <a:xfrm>
-            <a:off x="411480" y="6153912"/>
-            <a:ext cx="5212080" cy="347472"/>
+            <a:off x="6537960" y="2505456"/>
+            <a:ext cx="5120640" cy="594360"/>
           </a:xfrm>
           <a:prstGeom prst="rect">
             <a:avLst/>
@@ -5305,34 +4829,35 @@
           <a:p>
             <a:pPr algn="l"/>
             <a:r>
-              <a:rPr sz="1200" b="0" i="0">
+              <a:rPr sz="1100" b="0" i="0">
                 <a:solidFill>
-                  <a:srgbClr val="FFFFFF"/>
+                  <a:srgbClr val="7A7A7A"/>
                 </a:solidFill>
               </a:rPr>
-              <a:t>À définir selon localisation</a:t>
-            </a:r>
-          </a:p>
-        </p:txBody>
-      </p:sp>
-      <p:sp>
-        <p:nvSpPr>
-          <p:cNvPr id="29" name="Rounded Rectangle 28"/>
+              <a:t>Décoration pirate ultra-réaliste, idéale
+pour anniversaires et événements.</a:t>
+            </a:r>
+          </a:p>
+        </p:txBody>
+      </p:sp>
+      <p:sp>
+        <p:nvSpPr>
+          <p:cNvPr id="32" name="Rounded Rectangle 31"/>
           <p:cNvSpPr/>
           <p:nvPr/>
         </p:nvSpPr>
         <p:spPr>
           <a:xfrm>
-            <a:off x="6035040" y="1234440"/>
-            <a:ext cx="5897880" cy="5257800"/>
+            <a:off x="6099048" y="3273552"/>
+            <a:ext cx="5751576" cy="1078992"/>
           </a:xfrm>
           <a:prstGeom prst="roundRect">
             <a:avLst>
-              <a:gd name="adj" fmla="val 5000"/>
+              <a:gd name="adj" fmla="val 4000"/>
             </a:avLst>
           </a:prstGeom>
           <a:solidFill>
-            <a:srgbClr val="0D2452"/>
+            <a:srgbClr val="F9E4E1"/>
           </a:solidFill>
           <a:ln>
             <a:noFill/>
@@ -5362,56 +4887,22 @@
       </p:sp>
       <p:sp>
         <p:nvSpPr>
-          <p:cNvPr id="30" name="TextBox 29"/>
-          <p:cNvSpPr txBox="1"/>
-          <p:nvPr/>
-        </p:nvSpPr>
-        <p:spPr>
-          <a:xfrm>
-            <a:off x="6172200" y="1298448"/>
-            <a:ext cx="5577840" cy="457200"/>
-          </a:xfrm>
-          <a:prstGeom prst="rect">
-            <a:avLst/>
-          </a:prstGeom>
-          <a:noFill/>
-        </p:spPr>
-        <p:txBody>
-          <a:bodyPr wrap="square">
-            <a:spAutoFit/>
-          </a:bodyPr>
-          <a:lstStyle/>
-          <a:p>
-            <a:pPr algn="l"/>
-            <a:r>
-              <a:rPr sz="1600" b="1" i="0">
-                <a:solidFill>
-                  <a:srgbClr val="F5C518"/>
-                </a:solidFill>
-              </a:rPr>
-              <a:t>Points forts</a:t>
-            </a:r>
-          </a:p>
-        </p:txBody>
-      </p:sp>
-      <p:sp>
-        <p:nvSpPr>
-          <p:cNvPr id="31" name="Rounded Rectangle 30"/>
+          <p:cNvPr id="33" name="Rounded Rectangle 32"/>
           <p:cNvSpPr/>
           <p:nvPr/>
         </p:nvSpPr>
         <p:spPr>
           <a:xfrm>
-            <a:off x="6172200" y="1828800"/>
-            <a:ext cx="502920" cy="502920"/>
+            <a:off x="6263640" y="3566160"/>
+            <a:ext cx="164592" cy="164592"/>
           </a:xfrm>
           <a:prstGeom prst="roundRect">
             <a:avLst>
-              <a:gd name="adj" fmla="val 5000"/>
+              <a:gd name="adj" fmla="val 50000"/>
             </a:avLst>
           </a:prstGeom>
           <a:solidFill>
-            <a:srgbClr val="B88A00"/>
+            <a:srgbClr val="E87B6A"/>
           </a:solidFill>
           <a:ln>
             <a:noFill/>
@@ -5441,14 +4932,14 @@
       </p:sp>
       <p:sp>
         <p:nvSpPr>
-          <p:cNvPr id="32" name="TextBox 31"/>
+          <p:cNvPr id="34" name="TextBox 33"/>
           <p:cNvSpPr txBox="1"/>
           <p:nvPr/>
         </p:nvSpPr>
         <p:spPr>
           <a:xfrm>
-            <a:off x="6172200" y="1847088"/>
-            <a:ext cx="502920" cy="457200"/>
+            <a:off x="6537960" y="3364992"/>
+            <a:ext cx="5120640" cy="347472"/>
           </a:xfrm>
           <a:prstGeom prst="rect">
             <a:avLst/>
@@ -5461,28 +4952,28 @@
           </a:bodyPr>
           <a:lstStyle/>
           <a:p>
-            <a:pPr algn="ctr"/>
-            <a:r>
-              <a:rPr sz="2000" b="0" i="0">
+            <a:pPr algn="l"/>
+            <a:r>
+              <a:rPr sz="1300" b="1" i="0">
                 <a:solidFill>
-                  <a:srgbClr val="FFFFFF"/>
+                  <a:srgbClr val="2D2D2D"/>
                 </a:solidFill>
               </a:rPr>
-              <a:t>🏴‍☠️</a:t>
-            </a:r>
-          </a:p>
-        </p:txBody>
-      </p:sp>
-      <p:sp>
-        <p:nvSpPr>
-          <p:cNvPr id="33" name="TextBox 32"/>
+              <a:t>Multi-activités</a:t>
+            </a:r>
+          </a:p>
+        </p:txBody>
+      </p:sp>
+      <p:sp>
+        <p:nvSpPr>
+          <p:cNvPr id="35" name="TextBox 34"/>
           <p:cNvSpPr txBox="1"/>
           <p:nvPr/>
         </p:nvSpPr>
         <p:spPr>
           <a:xfrm>
-            <a:off x="6766560" y="1828800"/>
-            <a:ext cx="5029200" cy="411480"/>
+            <a:off x="6537960" y="3694176"/>
+            <a:ext cx="5120640" cy="594360"/>
           </a:xfrm>
           <a:prstGeom prst="rect">
             <a:avLst/>
@@ -5497,68 +4988,35 @@
           <a:p>
             <a:pPr algn="l"/>
             <a:r>
-              <a:rPr sz="1400" b="1" i="0">
+              <a:rPr sz="1100" b="0" i="0">
                 <a:solidFill>
-                  <a:srgbClr val="F5C518"/>
+                  <a:srgbClr val="7A7A7A"/>
                 </a:solidFill>
               </a:rPr>
-              <a:t>Thème Pirate immersif</a:t>
-            </a:r>
-          </a:p>
-        </p:txBody>
-      </p:sp>
-      <p:sp>
-        <p:nvSpPr>
-          <p:cNvPr id="34" name="TextBox 33"/>
-          <p:cNvSpPr txBox="1"/>
-          <p:nvPr/>
-        </p:nvSpPr>
-        <p:spPr>
-          <a:xfrm>
-            <a:off x="6766560" y="2212848"/>
-            <a:ext cx="5029200" cy="713232"/>
-          </a:xfrm>
-          <a:prstGeom prst="rect">
-            <a:avLst/>
-          </a:prstGeom>
-          <a:noFill/>
-        </p:spPr>
-        <p:txBody>
-          <a:bodyPr wrap="square">
-            <a:spAutoFit/>
-          </a:bodyPr>
-          <a:lstStyle/>
-          <a:p>
-            <a:pPr algn="l"/>
-            <a:r>
-              <a:rPr sz="1100" b="0" i="0">
-                <a:solidFill>
-                  <a:srgbClr val="D6EAF8"/>
-                </a:solidFill>
-              </a:rPr>
-              <a:t>Décoration pirates ultra-réaliste, idéale pour les anniversaires et événements.</a:t>
-            </a:r>
-          </a:p>
-        </p:txBody>
-      </p:sp>
-      <p:sp>
-        <p:nvSpPr>
-          <p:cNvPr id="35" name="Rounded Rectangle 34"/>
+              <a:t>Toboggan, escalade, parcours d'obstacles —
+plusieurs jeux en un seul module.</a:t>
+            </a:r>
+          </a:p>
+        </p:txBody>
+      </p:sp>
+      <p:sp>
+        <p:nvSpPr>
+          <p:cNvPr id="36" name="Rounded Rectangle 35"/>
           <p:cNvSpPr/>
           <p:nvPr/>
         </p:nvSpPr>
         <p:spPr>
           <a:xfrm>
-            <a:off x="6172200" y="3017520"/>
-            <a:ext cx="502920" cy="502920"/>
+            <a:off x="6099048" y="4462272"/>
+            <a:ext cx="5751576" cy="1078992"/>
           </a:xfrm>
           <a:prstGeom prst="roundRect">
             <a:avLst>
-              <a:gd name="adj" fmla="val 5000"/>
+              <a:gd name="adj" fmla="val 4000"/>
             </a:avLst>
           </a:prstGeom>
           <a:solidFill>
-            <a:srgbClr val="B88A00"/>
+            <a:srgbClr val="D6EDED"/>
           </a:solidFill>
           <a:ln>
             <a:noFill/>
@@ -5588,124 +5046,22 @@
       </p:sp>
       <p:sp>
         <p:nvSpPr>
-          <p:cNvPr id="36" name="TextBox 35"/>
-          <p:cNvSpPr txBox="1"/>
-          <p:nvPr/>
-        </p:nvSpPr>
-        <p:spPr>
-          <a:xfrm>
-            <a:off x="6172200" y="3035808"/>
-            <a:ext cx="502920" cy="457200"/>
-          </a:xfrm>
-          <a:prstGeom prst="rect">
-            <a:avLst/>
-          </a:prstGeom>
-          <a:noFill/>
-        </p:spPr>
-        <p:txBody>
-          <a:bodyPr wrap="square">
-            <a:spAutoFit/>
-          </a:bodyPr>
-          <a:lstStyle/>
-          <a:p>
-            <a:pPr algn="ctr"/>
-            <a:r>
-              <a:rPr sz="2000" b="0" i="0">
-                <a:solidFill>
-                  <a:srgbClr val="FFFFFF"/>
-                </a:solidFill>
-              </a:rPr>
-              <a:t>🎢</a:t>
-            </a:r>
-          </a:p>
-        </p:txBody>
-      </p:sp>
-      <p:sp>
-        <p:nvSpPr>
-          <p:cNvPr id="37" name="TextBox 36"/>
-          <p:cNvSpPr txBox="1"/>
-          <p:nvPr/>
-        </p:nvSpPr>
-        <p:spPr>
-          <a:xfrm>
-            <a:off x="6766560" y="3017520"/>
-            <a:ext cx="5029200" cy="411480"/>
-          </a:xfrm>
-          <a:prstGeom prst="rect">
-            <a:avLst/>
-          </a:prstGeom>
-          <a:noFill/>
-        </p:spPr>
-        <p:txBody>
-          <a:bodyPr wrap="square">
-            <a:spAutoFit/>
-          </a:bodyPr>
-          <a:lstStyle/>
-          <a:p>
-            <a:pPr algn="l"/>
-            <a:r>
-              <a:rPr sz="1400" b="1" i="0">
-                <a:solidFill>
-                  <a:srgbClr val="F5C518"/>
-                </a:solidFill>
-              </a:rPr>
-              <a:t>Multi-activités</a:t>
-            </a:r>
-          </a:p>
-        </p:txBody>
-      </p:sp>
-      <p:sp>
-        <p:nvSpPr>
-          <p:cNvPr id="38" name="TextBox 37"/>
-          <p:cNvSpPr txBox="1"/>
-          <p:nvPr/>
-        </p:nvSpPr>
-        <p:spPr>
-          <a:xfrm>
-            <a:off x="6766560" y="3401568"/>
-            <a:ext cx="5029200" cy="713232"/>
-          </a:xfrm>
-          <a:prstGeom prst="rect">
-            <a:avLst/>
-          </a:prstGeom>
-          <a:noFill/>
-        </p:spPr>
-        <p:txBody>
-          <a:bodyPr wrap="square">
-            <a:spAutoFit/>
-          </a:bodyPr>
-          <a:lstStyle/>
-          <a:p>
-            <a:pPr algn="l"/>
-            <a:r>
-              <a:rPr sz="1100" b="0" i="0">
-                <a:solidFill>
-                  <a:srgbClr val="D6EAF8"/>
-                </a:solidFill>
-              </a:rPr>
-              <a:t>Toboggan, parcours d'obstacles, escalade — plusieurs attractions en un seul module.</a:t>
-            </a:r>
-          </a:p>
-        </p:txBody>
-      </p:sp>
-      <p:sp>
-        <p:nvSpPr>
-          <p:cNvPr id="39" name="Rounded Rectangle 38"/>
+          <p:cNvPr id="37" name="Rounded Rectangle 36"/>
           <p:cNvSpPr/>
           <p:nvPr/>
         </p:nvSpPr>
         <p:spPr>
           <a:xfrm>
-            <a:off x="6172200" y="4206240"/>
-            <a:ext cx="502920" cy="502920"/>
+            <a:off x="6263640" y="4754880"/>
+            <a:ext cx="164592" cy="164592"/>
           </a:xfrm>
           <a:prstGeom prst="roundRect">
             <a:avLst>
-              <a:gd name="adj" fmla="val 5000"/>
+              <a:gd name="adj" fmla="val 50000"/>
             </a:avLst>
           </a:prstGeom>
           <a:solidFill>
-            <a:srgbClr val="B88A00"/>
+            <a:srgbClr val="4A9E9E"/>
           </a:solidFill>
           <a:ln>
             <a:noFill/>
@@ -5735,14 +5091,14 @@
       </p:sp>
       <p:sp>
         <p:nvSpPr>
-          <p:cNvPr id="40" name="TextBox 39"/>
+          <p:cNvPr id="38" name="TextBox 37"/>
           <p:cNvSpPr txBox="1"/>
           <p:nvPr/>
         </p:nvSpPr>
         <p:spPr>
           <a:xfrm>
-            <a:off x="6172200" y="4224527"/>
-            <a:ext cx="502920" cy="457200"/>
+            <a:off x="6537960" y="4553712"/>
+            <a:ext cx="5120640" cy="347472"/>
           </a:xfrm>
           <a:prstGeom prst="rect">
             <a:avLst/>
@@ -5755,28 +5111,28 @@
           </a:bodyPr>
           <a:lstStyle/>
           <a:p>
-            <a:pPr algn="ctr"/>
-            <a:r>
-              <a:rPr sz="2000" b="0" i="0">
+            <a:pPr algn="l"/>
+            <a:r>
+              <a:rPr sz="1300" b="1" i="0">
                 <a:solidFill>
-                  <a:srgbClr val="FFFFFF"/>
+                  <a:srgbClr val="2D2D2D"/>
                 </a:solidFill>
               </a:rPr>
-              <a:t>🔒</a:t>
-            </a:r>
-          </a:p>
-        </p:txBody>
-      </p:sp>
-      <p:sp>
-        <p:nvSpPr>
-          <p:cNvPr id="41" name="TextBox 40"/>
+              <a:t>Sécurité certifiée</a:t>
+            </a:r>
+          </a:p>
+        </p:txBody>
+      </p:sp>
+      <p:sp>
+        <p:nvSpPr>
+          <p:cNvPr id="39" name="TextBox 38"/>
           <p:cNvSpPr txBox="1"/>
           <p:nvPr/>
         </p:nvSpPr>
         <p:spPr>
           <a:xfrm>
-            <a:off x="6766560" y="4206240"/>
-            <a:ext cx="5029200" cy="411480"/>
+            <a:off x="6537960" y="4882896"/>
+            <a:ext cx="5120640" cy="594360"/>
           </a:xfrm>
           <a:prstGeom prst="rect">
             <a:avLst/>
@@ -5791,68 +5147,35 @@
           <a:p>
             <a:pPr algn="l"/>
             <a:r>
-              <a:rPr sz="1400" b="1" i="0">
+              <a:rPr sz="1100" b="0" i="0">
                 <a:solidFill>
-                  <a:srgbClr val="F5C518"/>
+                  <a:srgbClr val="7A7A7A"/>
                 </a:solidFill>
               </a:rPr>
-              <a:t>Sécurité certifiée</a:t>
-            </a:r>
-          </a:p>
-        </p:txBody>
-      </p:sp>
-      <p:sp>
-        <p:nvSpPr>
-          <p:cNvPr id="42" name="TextBox 41"/>
-          <p:cNvSpPr txBox="1"/>
-          <p:nvPr/>
-        </p:nvSpPr>
-        <p:spPr>
-          <a:xfrm>
-            <a:off x="6766560" y="4590288"/>
-            <a:ext cx="5029200" cy="713232"/>
-          </a:xfrm>
-          <a:prstGeom prst="rect">
-            <a:avLst/>
-          </a:prstGeom>
-          <a:noFill/>
-        </p:spPr>
-        <p:txBody>
-          <a:bodyPr wrap="square">
-            <a:spAutoFit/>
-          </a:bodyPr>
-          <a:lstStyle/>
-          <a:p>
-            <a:pPr algn="l"/>
-            <a:r>
-              <a:rPr sz="1100" b="0" i="0">
-                <a:solidFill>
-                  <a:srgbClr val="D6EAF8"/>
-                </a:solidFill>
-              </a:rPr>
-              <a:t>Conforme à la norme européenne EN 14960 pour les structures gonflables.</a:t>
-            </a:r>
-          </a:p>
-        </p:txBody>
-      </p:sp>
-      <p:sp>
-        <p:nvSpPr>
-          <p:cNvPr id="43" name="Rounded Rectangle 42"/>
+              <a:t>Norme EN 14960 — garantit la sécurité
+des utilisateurs enfants et adultes.</a:t>
+            </a:r>
+          </a:p>
+        </p:txBody>
+      </p:sp>
+      <p:sp>
+        <p:nvSpPr>
+          <p:cNvPr id="40" name="Rounded Rectangle 39"/>
           <p:cNvSpPr/>
           <p:nvPr/>
         </p:nvSpPr>
         <p:spPr>
           <a:xfrm>
-            <a:off x="6172200" y="5394960"/>
-            <a:ext cx="502920" cy="502920"/>
+            <a:off x="6099048" y="5650992"/>
+            <a:ext cx="5751576" cy="1078992"/>
           </a:xfrm>
           <a:prstGeom prst="roundRect">
             <a:avLst>
-              <a:gd name="adj" fmla="val 5000"/>
+              <a:gd name="adj" fmla="val 4000"/>
             </a:avLst>
           </a:prstGeom>
           <a:solidFill>
-            <a:srgbClr val="B88A00"/>
+            <a:srgbClr val="F9E4E1"/>
           </a:solidFill>
           <a:ln>
             <a:noFill/>
@@ -5882,14 +5205,59 @@
       </p:sp>
       <p:sp>
         <p:nvSpPr>
-          <p:cNvPr id="44" name="TextBox 43"/>
+          <p:cNvPr id="41" name="Rounded Rectangle 40"/>
+          <p:cNvSpPr/>
+          <p:nvPr/>
+        </p:nvSpPr>
+        <p:spPr>
+          <a:xfrm>
+            <a:off x="6263640" y="5943600"/>
+            <a:ext cx="164592" cy="164592"/>
+          </a:xfrm>
+          <a:prstGeom prst="roundRect">
+            <a:avLst>
+              <a:gd name="adj" fmla="val 50000"/>
+            </a:avLst>
+          </a:prstGeom>
+          <a:solidFill>
+            <a:srgbClr val="E87B6A"/>
+          </a:solidFill>
+          <a:ln>
+            <a:noFill/>
+          </a:ln>
+        </p:spPr>
+        <p:style>
+          <a:lnRef idx="1">
+            <a:schemeClr val="accent1"/>
+          </a:lnRef>
+          <a:fillRef idx="3">
+            <a:schemeClr val="accent1"/>
+          </a:fillRef>
+          <a:effectRef idx="2">
+            <a:schemeClr val="accent1"/>
+          </a:effectRef>
+          <a:fontRef idx="minor">
+            <a:schemeClr val="lt1"/>
+          </a:fontRef>
+        </p:style>
+        <p:txBody>
+          <a:bodyPr rtlCol="0" anchor="ctr"/>
+          <a:lstStyle/>
+          <a:p>
+            <a:pPr algn="ctr"/>
+          </a:p>
+        </p:txBody>
+      </p:sp>
+      <p:sp>
+        <p:nvSpPr>
+          <p:cNvPr id="42" name="TextBox 41"/>
           <p:cNvSpPr txBox="1"/>
           <p:nvPr/>
         </p:nvSpPr>
         <p:spPr>
           <a:xfrm>
-            <a:off x="6172200" y="5413248"/>
-            <a:ext cx="502920" cy="457200"/>
+            <a:off x="6537960" y="5742431"/>
+            <a:ext cx="5120640" cy="347472"/>
           </a:xfrm>
           <a:prstGeom prst="rect">
             <a:avLst/>
@@ -5902,28 +5270,28 @@
           </a:bodyPr>
           <a:lstStyle/>
           <a:p>
-            <a:pPr algn="ctr"/>
-            <a:r>
-              <a:rPr sz="2000" b="0" i="0">
+            <a:pPr algn="l"/>
+            <a:r>
+              <a:rPr sz="1300" b="1" i="0">
                 <a:solidFill>
-                  <a:srgbClr val="FFFFFF"/>
+                  <a:srgbClr val="2D2D2D"/>
                 </a:solidFill>
               </a:rPr>
-              <a:t>⚡</a:t>
-            </a:r>
-          </a:p>
-        </p:txBody>
-      </p:sp>
-      <p:sp>
-        <p:nvSpPr>
-          <p:cNvPr id="45" name="TextBox 44"/>
+              <a:t>Installation simple</a:t>
+            </a:r>
+          </a:p>
+        </p:txBody>
+      </p:sp>
+      <p:sp>
+        <p:nvSpPr>
+          <p:cNvPr id="43" name="TextBox 42"/>
           <p:cNvSpPr txBox="1"/>
           <p:nvPr/>
         </p:nvSpPr>
         <p:spPr>
           <a:xfrm>
-            <a:off x="6766560" y="5394960"/>
-            <a:ext cx="5029200" cy="411480"/>
+            <a:off x="6537960" y="6071616"/>
+            <a:ext cx="5120640" cy="594360"/>
           </a:xfrm>
           <a:prstGeom prst="rect">
             <a:avLst/>
@@ -5938,26 +5306,27 @@
           <a:p>
             <a:pPr algn="l"/>
             <a:r>
-              <a:rPr sz="1400" b="1" i="0">
+              <a:rPr sz="1100" b="0" i="0">
                 <a:solidFill>
-                  <a:srgbClr val="F5C518"/>
+                  <a:srgbClr val="7A7A7A"/>
                 </a:solidFill>
               </a:rPr>
-              <a:t>Installation facile</a:t>
-            </a:r>
-          </a:p>
-        </p:txBody>
-      </p:sp>
-      <p:sp>
-        <p:nvSpPr>
-          <p:cNvPr id="46" name="TextBox 45"/>
+              <a:t>Prise 220 V standard, gonflage rapide,
+prêt à l'emploi en quelques minutes.</a:t>
+            </a:r>
+          </a:p>
+        </p:txBody>
+      </p:sp>
+      <p:sp>
+        <p:nvSpPr>
+          <p:cNvPr id="44" name="TextBox 43"/>
           <p:cNvSpPr txBox="1"/>
           <p:nvPr/>
         </p:nvSpPr>
         <p:spPr>
           <a:xfrm>
-            <a:off x="6766560" y="5779008"/>
-            <a:ext cx="5029200" cy="713232"/>
+            <a:off x="320040" y="6537960"/>
+            <a:ext cx="11430000" cy="274320"/>
           </a:xfrm>
           <a:prstGeom prst="rect">
             <a:avLst/>
@@ -5972,46 +5341,12 @@
           <a:p>
             <a:pPr algn="l"/>
             <a:r>
-              <a:rPr sz="1100" b="0" i="0">
+              <a:rPr sz="800" b="0" i="0">
                 <a:solidFill>
-                  <a:srgbClr val="D6EAF8"/>
+                  <a:srgbClr val="7A7A7A"/>
                 </a:solidFill>
               </a:rPr>
-              <a:t>Branchement sur prise 220V standard, gonflage rapide inclus.</a:t>
-            </a:r>
-          </a:p>
-        </p:txBody>
-      </p:sp>
-      <p:sp>
-        <p:nvSpPr>
-          <p:cNvPr id="47" name="TextBox 46"/>
-          <p:cNvSpPr txBox="1"/>
-          <p:nvPr/>
-        </p:nvSpPr>
-        <p:spPr>
-          <a:xfrm>
-            <a:off x="274320" y="6492240"/>
-            <a:ext cx="11430000" cy="320040"/>
-          </a:xfrm>
-          <a:prstGeom prst="rect">
-            <a:avLst/>
-          </a:prstGeom>
-          <a:noFill/>
-        </p:spPr>
-        <p:txBody>
-          <a:bodyPr wrap="square">
-            <a:spAutoFit/>
-          </a:bodyPr>
-          <a:lstStyle/>
-          <a:p>
-            <a:pPr algn="l"/>
-            <a:r>
-              <a:rPr sz="900" b="0" i="0">
-                <a:solidFill>
-                  <a:srgbClr val="88AACC"/>
-                </a:solidFill>
-              </a:rPr>
-              <a:t>Source : https://jeux-gonflables.net — Parcours gonflable occasion #1359</a:t>
+              <a:t>jeux-gonflables.net — Parcours gonflable occasion #1359</a:t>
             </a:r>
           </a:p>
         </p:txBody>
@@ -6049,7 +5384,7 @@
             <a:avLst/>
           </a:prstGeom>
           <a:solidFill>
-            <a:srgbClr val="0A1F44"/>
+            <a:srgbClr val="FAF9F7"/>
           </a:solidFill>
           <a:ln>
             <a:noFill/>
@@ -6086,13 +5421,13 @@
         <p:spPr>
           <a:xfrm>
             <a:off x="0" y="0"/>
-            <a:ext cx="12188952" cy="109728"/>
+            <a:ext cx="54864" cy="6858000"/>
           </a:xfrm>
           <a:prstGeom prst="rect">
             <a:avLst/>
           </a:prstGeom>
           <a:solidFill>
-            <a:srgbClr val="F5C518"/>
+            <a:srgbClr val="4A9E9E"/>
           </a:solidFill>
           <a:ln>
             <a:noFill/>
@@ -6122,20 +5457,88 @@
       </p:sp>
       <p:sp>
         <p:nvSpPr>
-          <p:cNvPr id="4" name="Rectangle 3"/>
-          <p:cNvSpPr/>
-          <p:nvPr/>
-        </p:nvSpPr>
-        <p:spPr>
-          <a:xfrm>
-            <a:off x="0" y="6748272"/>
-            <a:ext cx="12188952" cy="109728"/>
+          <p:cNvPr id="4" name="TextBox 3"/>
+          <p:cNvSpPr txBox="1"/>
+          <p:nvPr/>
+        </p:nvSpPr>
+        <p:spPr>
+          <a:xfrm>
+            <a:off x="320040" y="292608"/>
+            <a:ext cx="9144000" cy="384048"/>
           </a:xfrm>
           <a:prstGeom prst="rect">
             <a:avLst/>
           </a:prstGeom>
+          <a:noFill/>
+        </p:spPr>
+        <p:txBody>
+          <a:bodyPr wrap="square">
+            <a:spAutoFit/>
+          </a:bodyPr>
+          <a:lstStyle/>
+          <a:p>
+            <a:pPr algn="l"/>
+            <a:r>
+              <a:rPr sz="1100" b="1" i="0">
+                <a:solidFill>
+                  <a:srgbClr val="4A9E9E"/>
+                </a:solidFill>
+              </a:rPr>
+              <a:t>POURQUOI CHOISIR CE PRODUIT ?</a:t>
+            </a:r>
+          </a:p>
+        </p:txBody>
+      </p:sp>
+      <p:sp>
+        <p:nvSpPr>
+          <p:cNvPr id="5" name="TextBox 4"/>
+          <p:cNvSpPr txBox="1"/>
+          <p:nvPr/>
+        </p:nvSpPr>
+        <p:spPr>
+          <a:xfrm>
+            <a:off x="320040" y="621792"/>
+            <a:ext cx="9144000" cy="548640"/>
+          </a:xfrm>
+          <a:prstGeom prst="rect">
+            <a:avLst/>
+          </a:prstGeom>
+          <a:noFill/>
+        </p:spPr>
+        <p:txBody>
+          <a:bodyPr wrap="square">
+            <a:spAutoFit/>
+          </a:bodyPr>
+          <a:lstStyle/>
+          <a:p>
+            <a:pPr algn="l"/>
+            <a:r>
+              <a:rPr sz="2800" b="1" i="0">
+                <a:solidFill>
+                  <a:srgbClr val="2D2D2D"/>
+                </a:solidFill>
+              </a:rPr>
+              <a:t>4 bonnes raisons</a:t>
+            </a:r>
+          </a:p>
+        </p:txBody>
+      </p:sp>
+      <p:sp>
+        <p:nvSpPr>
+          <p:cNvPr id="6" name="Rectangle 5"/>
+          <p:cNvSpPr/>
+          <p:nvPr/>
+        </p:nvSpPr>
+        <p:spPr>
+          <a:xfrm>
+            <a:off x="320040" y="1234440"/>
+            <a:ext cx="11521440" cy="27432"/>
+          </a:xfrm>
+          <a:prstGeom prst="rect">
+            <a:avLst/>
+          </a:prstGeom>
           <a:solidFill>
-            <a:srgbClr val="F5C518"/>
+            <a:srgbClr val="EEECE9"/>
           </a:solidFill>
           <a:ln>
             <a:noFill/>
@@ -6165,20 +5568,22 @@
       </p:sp>
       <p:sp>
         <p:nvSpPr>
-          <p:cNvPr id="5" name="Rectangle 4"/>
+          <p:cNvPr id="7" name="Rounded Rectangle 6"/>
           <p:cNvSpPr/>
           <p:nvPr/>
         </p:nvSpPr>
         <p:spPr>
           <a:xfrm>
-            <a:off x="0" y="109728"/>
-            <a:ext cx="73152" cy="6638544"/>
-          </a:xfrm>
-          <a:prstGeom prst="rect">
-            <a:avLst/>
+            <a:off x="320040" y="1417320"/>
+            <a:ext cx="5623560" cy="2331720"/>
+          </a:xfrm>
+          <a:prstGeom prst="roundRect">
+            <a:avLst>
+              <a:gd name="adj" fmla="val 4000"/>
+            </a:avLst>
           </a:prstGeom>
           <a:solidFill>
-            <a:srgbClr val="B88A00"/>
+            <a:srgbClr val="FFFFFF"/>
           </a:solidFill>
           <a:ln>
             <a:noFill/>
@@ -6208,20 +5613,20 @@
       </p:sp>
       <p:sp>
         <p:nvSpPr>
-          <p:cNvPr id="6" name="Rectangle 5"/>
+          <p:cNvPr id="8" name="Rectangle 7"/>
           <p:cNvSpPr/>
           <p:nvPr/>
         </p:nvSpPr>
         <p:spPr>
           <a:xfrm>
-            <a:off x="73152" y="109728"/>
-            <a:ext cx="12115800" cy="960120"/>
+            <a:off x="320040" y="1417320"/>
+            <a:ext cx="5623560" cy="45720"/>
           </a:xfrm>
           <a:prstGeom prst="rect">
             <a:avLst/>
           </a:prstGeom>
           <a:solidFill>
-            <a:srgbClr val="0E2755"/>
+            <a:srgbClr val="4A9E9E"/>
           </a:solidFill>
           <a:ln>
             <a:noFill/>
@@ -6251,56 +5656,22 @@
       </p:sp>
       <p:sp>
         <p:nvSpPr>
-          <p:cNvPr id="7" name="TextBox 6"/>
-          <p:cNvSpPr txBox="1"/>
-          <p:nvPr/>
-        </p:nvSpPr>
-        <p:spPr>
-          <a:xfrm>
-            <a:off x="274320" y="164592"/>
-            <a:ext cx="10972800" cy="822960"/>
-          </a:xfrm>
-          <a:prstGeom prst="rect">
-            <a:avLst/>
-          </a:prstGeom>
-          <a:noFill/>
-        </p:spPr>
-        <p:txBody>
-          <a:bodyPr wrap="square">
-            <a:spAutoFit/>
-          </a:bodyPr>
-          <a:lstStyle/>
-          <a:p>
-            <a:pPr algn="l"/>
-            <a:r>
-              <a:rPr sz="3000" b="1" i="0">
-                <a:solidFill>
-                  <a:srgbClr val="F5C518"/>
-                </a:solidFill>
-              </a:rPr>
-              <a:t>Pourquoi choisir ce château gonflable ?</a:t>
-            </a:r>
-          </a:p>
-        </p:txBody>
-      </p:sp>
-      <p:sp>
-        <p:nvSpPr>
-          <p:cNvPr id="8" name="Rounded Rectangle 7"/>
+          <p:cNvPr id="9" name="Rounded Rectangle 8"/>
           <p:cNvSpPr/>
           <p:nvPr/>
         </p:nvSpPr>
         <p:spPr>
           <a:xfrm>
-            <a:off x="502920" y="1325880"/>
-            <a:ext cx="5577840" cy="2377440"/>
+            <a:off x="548640" y="1618488"/>
+            <a:ext cx="411480" cy="411480"/>
           </a:xfrm>
           <a:prstGeom prst="roundRect">
             <a:avLst>
-              <a:gd name="adj" fmla="val 5000"/>
+              <a:gd name="adj" fmla="val 50000"/>
             </a:avLst>
           </a:prstGeom>
           <a:solidFill>
-            <a:srgbClr val="0E2755"/>
+            <a:srgbClr val="D6EDED"/>
           </a:solidFill>
           <a:ln>
             <a:noFill/>
@@ -6330,20 +5701,126 @@
       </p:sp>
       <p:sp>
         <p:nvSpPr>
-          <p:cNvPr id="9" name="Rectangle 8"/>
-          <p:cNvSpPr/>
-          <p:nvPr/>
-        </p:nvSpPr>
-        <p:spPr>
-          <a:xfrm>
-            <a:off x="502920" y="1325880"/>
-            <a:ext cx="5577840" cy="54864"/>
+          <p:cNvPr id="10" name="TextBox 9"/>
+          <p:cNvSpPr txBox="1"/>
+          <p:nvPr/>
+        </p:nvSpPr>
+        <p:spPr>
+          <a:xfrm>
+            <a:off x="676656" y="1682496"/>
+            <a:ext cx="182880" cy="274320"/>
           </a:xfrm>
           <a:prstGeom prst="rect">
             <a:avLst/>
           </a:prstGeom>
+          <a:noFill/>
+        </p:spPr>
+        <p:txBody>
+          <a:bodyPr wrap="square">
+            <a:spAutoFit/>
+          </a:bodyPr>
+          <a:lstStyle/>
+          <a:p>
+            <a:pPr algn="ctr"/>
+            <a:r>
+              <a:rPr sz="1000" b="0" i="0">
+                <a:solidFill>
+                  <a:srgbClr val="4A9E9E"/>
+                </a:solidFill>
+              </a:rPr>
+              <a:t>●</a:t>
+            </a:r>
+          </a:p>
+        </p:txBody>
+      </p:sp>
+      <p:sp>
+        <p:nvSpPr>
+          <p:cNvPr id="11" name="TextBox 10"/>
+          <p:cNvSpPr txBox="1"/>
+          <p:nvPr/>
+        </p:nvSpPr>
+        <p:spPr>
+          <a:xfrm>
+            <a:off x="1097280" y="1600200"/>
+            <a:ext cx="4663440" cy="384048"/>
+          </a:xfrm>
+          <a:prstGeom prst="rect">
+            <a:avLst/>
+          </a:prstGeom>
+          <a:noFill/>
+        </p:spPr>
+        <p:txBody>
+          <a:bodyPr wrap="square">
+            <a:spAutoFit/>
+          </a:bodyPr>
+          <a:lstStyle/>
+          <a:p>
+            <a:pPr algn="l"/>
+            <a:r>
+              <a:rPr sz="1500" b="1" i="0">
+                <a:solidFill>
+                  <a:srgbClr val="2D2D2D"/>
+                </a:solidFill>
+              </a:rPr>
+              <a:t>Prix compétitif</a:t>
+            </a:r>
+          </a:p>
+        </p:txBody>
+      </p:sp>
+      <p:sp>
+        <p:nvSpPr>
+          <p:cNvPr id="12" name="TextBox 11"/>
+          <p:cNvSpPr txBox="1"/>
+          <p:nvPr/>
+        </p:nvSpPr>
+        <p:spPr>
+          <a:xfrm>
+            <a:off x="548640" y="2167128"/>
+            <a:ext cx="5212080" cy="1417320"/>
+          </a:xfrm>
+          <a:prstGeom prst="rect">
+            <a:avLst/>
+          </a:prstGeom>
+          <a:noFill/>
+        </p:spPr>
+        <p:txBody>
+          <a:bodyPr wrap="square">
+            <a:spAutoFit/>
+          </a:bodyPr>
+          <a:lstStyle/>
+          <a:p>
+            <a:pPr algn="l"/>
+            <a:r>
+              <a:rPr sz="1200" b="0" i="0">
+                <a:solidFill>
+                  <a:srgbClr val="7A7A7A"/>
+                </a:solidFill>
+              </a:rPr>
+              <a:t>1 700 € HT pour une structure
+de grande dimension avec
+plusieurs activités intégrées.</a:t>
+            </a:r>
+          </a:p>
+        </p:txBody>
+      </p:sp>
+      <p:sp>
+        <p:nvSpPr>
+          <p:cNvPr id="13" name="Rounded Rectangle 12"/>
+          <p:cNvSpPr/>
+          <p:nvPr/>
+        </p:nvSpPr>
+        <p:spPr>
+          <a:xfrm>
+            <a:off x="6281927" y="1417320"/>
+            <a:ext cx="5623560" cy="2331720"/>
+          </a:xfrm>
+          <a:prstGeom prst="roundRect">
+            <a:avLst>
+              <a:gd name="adj" fmla="val 4000"/>
+            </a:avLst>
+          </a:prstGeom>
           <a:solidFill>
-            <a:srgbClr val="F5C518"/>
+            <a:srgbClr val="FFFFFF"/>
           </a:solidFill>
           <a:ln>
             <a:noFill/>
@@ -6373,126 +5850,20 @@
       </p:sp>
       <p:sp>
         <p:nvSpPr>
-          <p:cNvPr id="10" name="TextBox 9"/>
-          <p:cNvSpPr txBox="1"/>
-          <p:nvPr/>
-        </p:nvSpPr>
-        <p:spPr>
-          <a:xfrm>
-            <a:off x="731520" y="1463039"/>
-            <a:ext cx="640080" cy="640080"/>
+          <p:cNvPr id="14" name="Rectangle 13"/>
+          <p:cNvSpPr/>
+          <p:nvPr/>
+        </p:nvSpPr>
+        <p:spPr>
+          <a:xfrm>
+            <a:off x="6281927" y="1417320"/>
+            <a:ext cx="5623560" cy="45720"/>
           </a:xfrm>
           <a:prstGeom prst="rect">
             <a:avLst/>
           </a:prstGeom>
-          <a:noFill/>
-        </p:spPr>
-        <p:txBody>
-          <a:bodyPr wrap="square">
-            <a:spAutoFit/>
-          </a:bodyPr>
-          <a:lstStyle/>
-          <a:p>
-            <a:pPr algn="l"/>
-            <a:r>
-              <a:rPr sz="3200" b="0" i="0">
-                <a:solidFill>
-                  <a:srgbClr val="FFFFFF"/>
-                </a:solidFill>
-              </a:rPr>
-              <a:t>💰</a:t>
-            </a:r>
-          </a:p>
-        </p:txBody>
-      </p:sp>
-      <p:sp>
-        <p:nvSpPr>
-          <p:cNvPr id="11" name="TextBox 10"/>
-          <p:cNvSpPr txBox="1"/>
-          <p:nvPr/>
-        </p:nvSpPr>
-        <p:spPr>
-          <a:xfrm>
-            <a:off x="1463040" y="1490472"/>
-            <a:ext cx="4389120" cy="502920"/>
-          </a:xfrm>
-          <a:prstGeom prst="rect">
-            <a:avLst/>
-          </a:prstGeom>
-          <a:noFill/>
-        </p:spPr>
-        <p:txBody>
-          <a:bodyPr wrap="square">
-            <a:spAutoFit/>
-          </a:bodyPr>
-          <a:lstStyle/>
-          <a:p>
-            <a:pPr algn="l"/>
-            <a:r>
-              <a:rPr sz="1800" b="1" i="0">
-                <a:solidFill>
-                  <a:srgbClr val="F5C518"/>
-                </a:solidFill>
-              </a:rPr>
-              <a:t>Prix compétitif</a:t>
-            </a:r>
-          </a:p>
-        </p:txBody>
-      </p:sp>
-      <p:sp>
-        <p:nvSpPr>
-          <p:cNvPr id="12" name="TextBox 11"/>
-          <p:cNvSpPr txBox="1"/>
-          <p:nvPr/>
-        </p:nvSpPr>
-        <p:spPr>
-          <a:xfrm>
-            <a:off x="731520" y="2103120"/>
-            <a:ext cx="5120640" cy="1463040"/>
-          </a:xfrm>
-          <a:prstGeom prst="rect">
-            <a:avLst/>
-          </a:prstGeom>
-          <a:noFill/>
-        </p:spPr>
-        <p:txBody>
-          <a:bodyPr wrap="square">
-            <a:spAutoFit/>
-          </a:bodyPr>
-          <a:lstStyle/>
-          <a:p>
-            <a:pPr algn="l"/>
-            <a:r>
-              <a:rPr sz="1300" b="0" i="0">
-                <a:solidFill>
-                  <a:srgbClr val="D6EAF8"/>
-                </a:solidFill>
-              </a:rPr>
-              <a:t>1 700 € HT seulement pour
-une structure multiactivités
-de grande dimension.</a:t>
-            </a:r>
-          </a:p>
-        </p:txBody>
-      </p:sp>
-      <p:sp>
-        <p:nvSpPr>
-          <p:cNvPr id="13" name="Rounded Rectangle 12"/>
-          <p:cNvSpPr/>
-          <p:nvPr/>
-        </p:nvSpPr>
-        <p:spPr>
-          <a:xfrm>
-            <a:off x="6400800" y="1325880"/>
-            <a:ext cx="5577840" cy="2377440"/>
-          </a:xfrm>
-          <a:prstGeom prst="roundRect">
-            <a:avLst>
-              <a:gd name="adj" fmla="val 5000"/>
-            </a:avLst>
-          </a:prstGeom>
           <a:solidFill>
-            <a:srgbClr val="0E2755"/>
+            <a:srgbClr val="E87B6A"/>
           </a:solidFill>
           <a:ln>
             <a:noFill/>
@@ -6522,20 +5893,22 @@
       </p:sp>
       <p:sp>
         <p:nvSpPr>
-          <p:cNvPr id="14" name="Rectangle 13"/>
+          <p:cNvPr id="15" name="Rounded Rectangle 14"/>
           <p:cNvSpPr/>
           <p:nvPr/>
         </p:nvSpPr>
         <p:spPr>
           <a:xfrm>
-            <a:off x="6400800" y="1325880"/>
-            <a:ext cx="5577840" cy="54864"/>
-          </a:xfrm>
-          <a:prstGeom prst="rect">
-            <a:avLst/>
+            <a:off x="6510527" y="1618488"/>
+            <a:ext cx="411480" cy="411480"/>
+          </a:xfrm>
+          <a:prstGeom prst="roundRect">
+            <a:avLst>
+              <a:gd name="adj" fmla="val 50000"/>
+            </a:avLst>
           </a:prstGeom>
           <a:solidFill>
-            <a:srgbClr val="F5C518"/>
+            <a:srgbClr val="F9E4E1"/>
           </a:solidFill>
           <a:ln>
             <a:noFill/>
@@ -6565,14 +5938,14 @@
       </p:sp>
       <p:sp>
         <p:nvSpPr>
-          <p:cNvPr id="15" name="TextBox 14"/>
+          <p:cNvPr id="16" name="TextBox 15"/>
           <p:cNvSpPr txBox="1"/>
           <p:nvPr/>
         </p:nvSpPr>
         <p:spPr>
           <a:xfrm>
-            <a:off x="6629400" y="1463039"/>
-            <a:ext cx="640080" cy="640080"/>
+            <a:off x="6638543" y="1682496"/>
+            <a:ext cx="182880" cy="274320"/>
           </a:xfrm>
           <a:prstGeom prst="rect">
             <a:avLst/>
@@ -6585,28 +5958,28 @@
           </a:bodyPr>
           <a:lstStyle/>
           <a:p>
-            <a:pPr algn="l"/>
-            <a:r>
-              <a:rPr sz="3200" b="0" i="0">
+            <a:pPr algn="ctr"/>
+            <a:r>
+              <a:rPr sz="1000" b="0" i="0">
                 <a:solidFill>
-                  <a:srgbClr val="FFFFFF"/>
+                  <a:srgbClr val="E87B6A"/>
                 </a:solidFill>
               </a:rPr>
-              <a:t>📐</a:t>
-            </a:r>
-          </a:p>
-        </p:txBody>
-      </p:sp>
-      <p:sp>
-        <p:nvSpPr>
-          <p:cNvPr id="16" name="TextBox 15"/>
+              <a:t>●</a:t>
+            </a:r>
+          </a:p>
+        </p:txBody>
+      </p:sp>
+      <p:sp>
+        <p:nvSpPr>
+          <p:cNvPr id="17" name="TextBox 16"/>
           <p:cNvSpPr txBox="1"/>
           <p:nvPr/>
         </p:nvSpPr>
         <p:spPr>
           <a:xfrm>
-            <a:off x="7360920" y="1490472"/>
-            <a:ext cx="4389120" cy="502920"/>
+            <a:off x="7059167" y="1600200"/>
+            <a:ext cx="4663440" cy="384048"/>
           </a:xfrm>
           <a:prstGeom prst="rect">
             <a:avLst/>
@@ -6621,9 +5994,9 @@
           <a:p>
             <a:pPr algn="l"/>
             <a:r>
-              <a:rPr sz="1800" b="1" i="0">
+              <a:rPr sz="1500" b="1" i="0">
                 <a:solidFill>
-                  <a:srgbClr val="F5C518"/>
+                  <a:srgbClr val="2D2D2D"/>
                 </a:solidFill>
               </a:rPr>
               <a:t>Grande superficie</a:t>
@@ -6633,14 +6006,14 @@
       </p:sp>
       <p:sp>
         <p:nvSpPr>
-          <p:cNvPr id="17" name="TextBox 16"/>
+          <p:cNvPr id="18" name="TextBox 17"/>
           <p:cNvSpPr txBox="1"/>
           <p:nvPr/>
         </p:nvSpPr>
         <p:spPr>
           <a:xfrm>
-            <a:off x="6629400" y="2103120"/>
-            <a:ext cx="5120640" cy="1463040"/>
+            <a:off x="6510527" y="2167128"/>
+            <a:ext cx="5212080" cy="1417320"/>
           </a:xfrm>
           <a:prstGeom prst="rect">
             <a:avLst/>
@@ -6655,36 +6028,36 @@
           <a:p>
             <a:pPr algn="l"/>
             <a:r>
-              <a:rPr sz="1300" b="0" i="0">
+              <a:rPr sz="1200" b="0" i="0">
                 <a:solidFill>
-                  <a:srgbClr val="D6EAF8"/>
+                  <a:srgbClr val="7A7A7A"/>
                 </a:solidFill>
               </a:rPr>
-              <a:t>8 × 5,1 × 4,3 m offrent
-un espace de jeu généreux
-pour les enfants.</a:t>
-            </a:r>
-          </a:p>
-        </p:txBody>
-      </p:sp>
-      <p:sp>
-        <p:nvSpPr>
-          <p:cNvPr id="18" name="Rounded Rectangle 17"/>
+              <a:t>8 × 5,1 × 4,3 m — un espace
+de jeu généreux adapté
+aux enfants comme aux adultes.</a:t>
+            </a:r>
+          </a:p>
+        </p:txBody>
+      </p:sp>
+      <p:sp>
+        <p:nvSpPr>
+          <p:cNvPr id="19" name="Rounded Rectangle 18"/>
           <p:cNvSpPr/>
           <p:nvPr/>
         </p:nvSpPr>
         <p:spPr>
           <a:xfrm>
-            <a:off x="502920" y="3931920"/>
-            <a:ext cx="5577840" cy="2377440"/>
+            <a:off x="320040" y="3959352"/>
+            <a:ext cx="5623560" cy="2331720"/>
           </a:xfrm>
           <a:prstGeom prst="roundRect">
             <a:avLst>
-              <a:gd name="adj" fmla="val 5000"/>
+              <a:gd name="adj" fmla="val 4000"/>
             </a:avLst>
           </a:prstGeom>
           <a:solidFill>
-            <a:srgbClr val="0E2755"/>
+            <a:srgbClr val="FFFFFF"/>
           </a:solidFill>
           <a:ln>
             <a:noFill/>
@@ -6714,20 +6087,20 @@
       </p:sp>
       <p:sp>
         <p:nvSpPr>
-          <p:cNvPr id="19" name="Rectangle 18"/>
+          <p:cNvPr id="20" name="Rectangle 19"/>
           <p:cNvSpPr/>
           <p:nvPr/>
         </p:nvSpPr>
         <p:spPr>
           <a:xfrm>
-            <a:off x="502920" y="3931920"/>
-            <a:ext cx="5577840" cy="54864"/>
+            <a:off x="320040" y="3959352"/>
+            <a:ext cx="5623560" cy="45720"/>
           </a:xfrm>
           <a:prstGeom prst="rect">
             <a:avLst/>
           </a:prstGeom>
           <a:solidFill>
-            <a:srgbClr val="F5C518"/>
+            <a:srgbClr val="4A9E9E"/>
           </a:solidFill>
           <a:ln>
             <a:noFill/>
@@ -6757,126 +6130,22 @@
       </p:sp>
       <p:sp>
         <p:nvSpPr>
-          <p:cNvPr id="20" name="TextBox 19"/>
-          <p:cNvSpPr txBox="1"/>
-          <p:nvPr/>
-        </p:nvSpPr>
-        <p:spPr>
-          <a:xfrm>
-            <a:off x="731520" y="4069080"/>
-            <a:ext cx="640080" cy="640080"/>
-          </a:xfrm>
-          <a:prstGeom prst="rect">
-            <a:avLst/>
-          </a:prstGeom>
-          <a:noFill/>
-        </p:spPr>
-        <p:txBody>
-          <a:bodyPr wrap="square">
-            <a:spAutoFit/>
-          </a:bodyPr>
-          <a:lstStyle/>
-          <a:p>
-            <a:pPr algn="l"/>
-            <a:r>
-              <a:rPr sz="3200" b="0" i="0">
-                <a:solidFill>
-                  <a:srgbClr val="FFFFFF"/>
-                </a:solidFill>
-              </a:rPr>
-              <a:t>🎉</a:t>
-            </a:r>
-          </a:p>
-        </p:txBody>
-      </p:sp>
-      <p:sp>
-        <p:nvSpPr>
-          <p:cNvPr id="21" name="TextBox 20"/>
-          <p:cNvSpPr txBox="1"/>
-          <p:nvPr/>
-        </p:nvSpPr>
-        <p:spPr>
-          <a:xfrm>
-            <a:off x="1463040" y="4096511"/>
-            <a:ext cx="4389120" cy="502920"/>
-          </a:xfrm>
-          <a:prstGeom prst="rect">
-            <a:avLst/>
-          </a:prstGeom>
-          <a:noFill/>
-        </p:spPr>
-        <p:txBody>
-          <a:bodyPr wrap="square">
-            <a:spAutoFit/>
-          </a:bodyPr>
-          <a:lstStyle/>
-          <a:p>
-            <a:pPr algn="l"/>
-            <a:r>
-              <a:rPr sz="1800" b="1" i="0">
-                <a:solidFill>
-                  <a:srgbClr val="F5C518"/>
-                </a:solidFill>
-              </a:rPr>
-              <a:t>Polyvalent</a:t>
-            </a:r>
-          </a:p>
-        </p:txBody>
-      </p:sp>
-      <p:sp>
-        <p:nvSpPr>
-          <p:cNvPr id="22" name="TextBox 21"/>
-          <p:cNvSpPr txBox="1"/>
-          <p:nvPr/>
-        </p:nvSpPr>
-        <p:spPr>
-          <a:xfrm>
-            <a:off x="731520" y="4709159"/>
-            <a:ext cx="5120640" cy="1463040"/>
-          </a:xfrm>
-          <a:prstGeom prst="rect">
-            <a:avLst/>
-          </a:prstGeom>
-          <a:noFill/>
-        </p:spPr>
-        <p:txBody>
-          <a:bodyPr wrap="square">
-            <a:spAutoFit/>
-          </a:bodyPr>
-          <a:lstStyle/>
-          <a:p>
-            <a:pPr algn="l"/>
-            <a:r>
-              <a:rPr sz="1300" b="0" i="0">
-                <a:solidFill>
-                  <a:srgbClr val="D6EAF8"/>
-                </a:solidFill>
-              </a:rPr>
-              <a:t>Parfait pour locations,
-animations événementielles,
-centres de loisirs.</a:t>
-            </a:r>
-          </a:p>
-        </p:txBody>
-      </p:sp>
-      <p:sp>
-        <p:nvSpPr>
-          <p:cNvPr id="23" name="Rounded Rectangle 22"/>
+          <p:cNvPr id="21" name="Rounded Rectangle 20"/>
           <p:cNvSpPr/>
           <p:nvPr/>
         </p:nvSpPr>
         <p:spPr>
           <a:xfrm>
-            <a:off x="6400800" y="3931920"/>
-            <a:ext cx="5577840" cy="2377440"/>
+            <a:off x="548640" y="4160520"/>
+            <a:ext cx="411480" cy="411480"/>
           </a:xfrm>
           <a:prstGeom prst="roundRect">
             <a:avLst>
-              <a:gd name="adj" fmla="val 5000"/>
+              <a:gd name="adj" fmla="val 50000"/>
             </a:avLst>
           </a:prstGeom>
           <a:solidFill>
-            <a:srgbClr val="0E2755"/>
+            <a:srgbClr val="D6EDED"/>
           </a:solidFill>
           <a:ln>
             <a:noFill/>
@@ -6906,20 +6175,126 @@
       </p:sp>
       <p:sp>
         <p:nvSpPr>
-          <p:cNvPr id="24" name="Rectangle 23"/>
-          <p:cNvSpPr/>
-          <p:nvPr/>
-        </p:nvSpPr>
-        <p:spPr>
-          <a:xfrm>
-            <a:off x="6400800" y="3931920"/>
-            <a:ext cx="5577840" cy="54864"/>
+          <p:cNvPr id="22" name="TextBox 21"/>
+          <p:cNvSpPr txBox="1"/>
+          <p:nvPr/>
+        </p:nvSpPr>
+        <p:spPr>
+          <a:xfrm>
+            <a:off x="676656" y="4224528"/>
+            <a:ext cx="182880" cy="274320"/>
           </a:xfrm>
           <a:prstGeom prst="rect">
             <a:avLst/>
           </a:prstGeom>
+          <a:noFill/>
+        </p:spPr>
+        <p:txBody>
+          <a:bodyPr wrap="square">
+            <a:spAutoFit/>
+          </a:bodyPr>
+          <a:lstStyle/>
+          <a:p>
+            <a:pPr algn="ctr"/>
+            <a:r>
+              <a:rPr sz="1000" b="0" i="0">
+                <a:solidFill>
+                  <a:srgbClr val="4A9E9E"/>
+                </a:solidFill>
+              </a:rPr>
+              <a:t>●</a:t>
+            </a:r>
+          </a:p>
+        </p:txBody>
+      </p:sp>
+      <p:sp>
+        <p:nvSpPr>
+          <p:cNvPr id="23" name="TextBox 22"/>
+          <p:cNvSpPr txBox="1"/>
+          <p:nvPr/>
+        </p:nvSpPr>
+        <p:spPr>
+          <a:xfrm>
+            <a:off x="1097280" y="4142232"/>
+            <a:ext cx="4663440" cy="384048"/>
+          </a:xfrm>
+          <a:prstGeom prst="rect">
+            <a:avLst/>
+          </a:prstGeom>
+          <a:noFill/>
+        </p:spPr>
+        <p:txBody>
+          <a:bodyPr wrap="square">
+            <a:spAutoFit/>
+          </a:bodyPr>
+          <a:lstStyle/>
+          <a:p>
+            <a:pPr algn="l"/>
+            <a:r>
+              <a:rPr sz="1500" b="1" i="0">
+                <a:solidFill>
+                  <a:srgbClr val="2D2D2D"/>
+                </a:solidFill>
+              </a:rPr>
+              <a:t>Très polyvalent</a:t>
+            </a:r>
+          </a:p>
+        </p:txBody>
+      </p:sp>
+      <p:sp>
+        <p:nvSpPr>
+          <p:cNvPr id="24" name="TextBox 23"/>
+          <p:cNvSpPr txBox="1"/>
+          <p:nvPr/>
+        </p:nvSpPr>
+        <p:spPr>
+          <a:xfrm>
+            <a:off x="548640" y="4709160"/>
+            <a:ext cx="5212080" cy="1417320"/>
+          </a:xfrm>
+          <a:prstGeom prst="rect">
+            <a:avLst/>
+          </a:prstGeom>
+          <a:noFill/>
+        </p:spPr>
+        <p:txBody>
+          <a:bodyPr wrap="square">
+            <a:spAutoFit/>
+          </a:bodyPr>
+          <a:lstStyle/>
+          <a:p>
+            <a:pPr algn="l"/>
+            <a:r>
+              <a:rPr sz="1200" b="0" i="0">
+                <a:solidFill>
+                  <a:srgbClr val="7A7A7A"/>
+                </a:solidFill>
+              </a:rPr>
+              <a:t>Idéal pour la location,
+les animations événementielles
+et les centres de loisirs.</a:t>
+            </a:r>
+          </a:p>
+        </p:txBody>
+      </p:sp>
+      <p:sp>
+        <p:nvSpPr>
+          <p:cNvPr id="25" name="Rounded Rectangle 24"/>
+          <p:cNvSpPr/>
+          <p:nvPr/>
+        </p:nvSpPr>
+        <p:spPr>
+          <a:xfrm>
+            <a:off x="6281927" y="3959352"/>
+            <a:ext cx="5623560" cy="2331720"/>
+          </a:xfrm>
+          <a:prstGeom prst="roundRect">
+            <a:avLst>
+              <a:gd name="adj" fmla="val 4000"/>
+            </a:avLst>
+          </a:prstGeom>
           <a:solidFill>
-            <a:srgbClr val="F5C518"/>
+            <a:srgbClr val="FFFFFF"/>
           </a:solidFill>
           <a:ln>
             <a:noFill/>
@@ -6949,126 +6324,20 @@
       </p:sp>
       <p:sp>
         <p:nvSpPr>
-          <p:cNvPr id="25" name="TextBox 24"/>
-          <p:cNvSpPr txBox="1"/>
-          <p:nvPr/>
-        </p:nvSpPr>
-        <p:spPr>
-          <a:xfrm>
-            <a:off x="6629400" y="4069080"/>
-            <a:ext cx="640080" cy="640080"/>
+          <p:cNvPr id="26" name="Rectangle 25"/>
+          <p:cNvSpPr/>
+          <p:nvPr/>
+        </p:nvSpPr>
+        <p:spPr>
+          <a:xfrm>
+            <a:off x="6281927" y="3959352"/>
+            <a:ext cx="5623560" cy="45720"/>
           </a:xfrm>
           <a:prstGeom prst="rect">
             <a:avLst/>
           </a:prstGeom>
-          <a:noFill/>
-        </p:spPr>
-        <p:txBody>
-          <a:bodyPr wrap="square">
-            <a:spAutoFit/>
-          </a:bodyPr>
-          <a:lstStyle/>
-          <a:p>
-            <a:pPr algn="l"/>
-            <a:r>
-              <a:rPr sz="3200" b="0" i="0">
-                <a:solidFill>
-                  <a:srgbClr val="FFFFFF"/>
-                </a:solidFill>
-              </a:rPr>
-              <a:t>🛡️</a:t>
-            </a:r>
-          </a:p>
-        </p:txBody>
-      </p:sp>
-      <p:sp>
-        <p:nvSpPr>
-          <p:cNvPr id="26" name="TextBox 25"/>
-          <p:cNvSpPr txBox="1"/>
-          <p:nvPr/>
-        </p:nvSpPr>
-        <p:spPr>
-          <a:xfrm>
-            <a:off x="7360920" y="4096511"/>
-            <a:ext cx="4389120" cy="502920"/>
-          </a:xfrm>
-          <a:prstGeom prst="rect">
-            <a:avLst/>
-          </a:prstGeom>
-          <a:noFill/>
-        </p:spPr>
-        <p:txBody>
-          <a:bodyPr wrap="square">
-            <a:spAutoFit/>
-          </a:bodyPr>
-          <a:lstStyle/>
-          <a:p>
-            <a:pPr algn="l"/>
-            <a:r>
-              <a:rPr sz="1800" b="1" i="0">
-                <a:solidFill>
-                  <a:srgbClr val="F5C518"/>
-                </a:solidFill>
-              </a:rPr>
-              <a:t>Normes européennes</a:t>
-            </a:r>
-          </a:p>
-        </p:txBody>
-      </p:sp>
-      <p:sp>
-        <p:nvSpPr>
-          <p:cNvPr id="27" name="TextBox 26"/>
-          <p:cNvSpPr txBox="1"/>
-          <p:nvPr/>
-        </p:nvSpPr>
-        <p:spPr>
-          <a:xfrm>
-            <a:off x="6629400" y="4709159"/>
-            <a:ext cx="5120640" cy="1463040"/>
-          </a:xfrm>
-          <a:prstGeom prst="rect">
-            <a:avLst/>
-          </a:prstGeom>
-          <a:noFill/>
-        </p:spPr>
-        <p:txBody>
-          <a:bodyPr wrap="square">
-            <a:spAutoFit/>
-          </a:bodyPr>
-          <a:lstStyle/>
-          <a:p>
-            <a:pPr algn="l"/>
-            <a:r>
-              <a:rPr sz="1300" b="0" i="0">
-                <a:solidFill>
-                  <a:srgbClr val="D6EAF8"/>
-                </a:solidFill>
-              </a:rPr>
-              <a:t>Certification EN 14960
-garantit la sécurité
-de tous les utilisateurs.</a:t>
-            </a:r>
-          </a:p>
-        </p:txBody>
-      </p:sp>
-      <p:sp>
-        <p:nvSpPr>
-          <p:cNvPr id="28" name="Rounded Rectangle 27"/>
-          <p:cNvSpPr/>
-          <p:nvPr/>
-        </p:nvSpPr>
-        <p:spPr>
-          <a:xfrm>
-            <a:off x="2286000" y="6400800"/>
-            <a:ext cx="7616952" cy="320040"/>
-          </a:xfrm>
-          <a:prstGeom prst="roundRect">
-            <a:avLst>
-              <a:gd name="adj" fmla="val 5000"/>
-            </a:avLst>
-          </a:prstGeom>
           <a:solidFill>
-            <a:srgbClr val="CC1F1F"/>
+            <a:srgbClr val="E87B6A"/>
           </a:solidFill>
           <a:ln>
             <a:noFill/>
@@ -7098,14 +6367,59 @@
       </p:sp>
       <p:sp>
         <p:nvSpPr>
-          <p:cNvPr id="29" name="TextBox 28"/>
+          <p:cNvPr id="27" name="Rounded Rectangle 26"/>
+          <p:cNvSpPr/>
+          <p:nvPr/>
+        </p:nvSpPr>
+        <p:spPr>
+          <a:xfrm>
+            <a:off x="6510527" y="4160520"/>
+            <a:ext cx="411480" cy="411480"/>
+          </a:xfrm>
+          <a:prstGeom prst="roundRect">
+            <a:avLst>
+              <a:gd name="adj" fmla="val 50000"/>
+            </a:avLst>
+          </a:prstGeom>
+          <a:solidFill>
+            <a:srgbClr val="F9E4E1"/>
+          </a:solidFill>
+          <a:ln>
+            <a:noFill/>
+          </a:ln>
+        </p:spPr>
+        <p:style>
+          <a:lnRef idx="1">
+            <a:schemeClr val="accent1"/>
+          </a:lnRef>
+          <a:fillRef idx="3">
+            <a:schemeClr val="accent1"/>
+          </a:fillRef>
+          <a:effectRef idx="2">
+            <a:schemeClr val="accent1"/>
+          </a:effectRef>
+          <a:fontRef idx="minor">
+            <a:schemeClr val="lt1"/>
+          </a:fontRef>
+        </p:style>
+        <p:txBody>
+          <a:bodyPr rtlCol="0" anchor="ctr"/>
+          <a:lstStyle/>
+          <a:p>
+            <a:pPr algn="ctr"/>
+          </a:p>
+        </p:txBody>
+      </p:sp>
+      <p:sp>
+        <p:nvSpPr>
+          <p:cNvPr id="28" name="TextBox 27"/>
           <p:cNvSpPr txBox="1"/>
           <p:nvPr/>
         </p:nvSpPr>
         <p:spPr>
           <a:xfrm>
-            <a:off x="274320" y="6473952"/>
-            <a:ext cx="11521440" cy="320040"/>
+            <a:off x="6638543" y="4224528"/>
+            <a:ext cx="182880" cy="274320"/>
           </a:xfrm>
           <a:prstGeom prst="rect">
             <a:avLst/>
@@ -7120,12 +6434,161 @@
           <a:p>
             <a:pPr algn="ctr"/>
             <a:r>
-              <a:rPr sz="1100" b="1" i="0">
+              <a:rPr sz="1000" b="0" i="0">
                 <a:solidFill>
-                  <a:srgbClr val="FFFFFF"/>
+                  <a:srgbClr val="E87B6A"/>
                 </a:solidFill>
               </a:rPr>
-              <a:t>Contactez-nous pour plus d'informations · jeux-gonflables.net</a:t>
+              <a:t>●</a:t>
+            </a:r>
+          </a:p>
+        </p:txBody>
+      </p:sp>
+      <p:sp>
+        <p:nvSpPr>
+          <p:cNvPr id="29" name="TextBox 28"/>
+          <p:cNvSpPr txBox="1"/>
+          <p:nvPr/>
+        </p:nvSpPr>
+        <p:spPr>
+          <a:xfrm>
+            <a:off x="7059167" y="4142232"/>
+            <a:ext cx="4663440" cy="384048"/>
+          </a:xfrm>
+          <a:prstGeom prst="rect">
+            <a:avLst/>
+          </a:prstGeom>
+          <a:noFill/>
+        </p:spPr>
+        <p:txBody>
+          <a:bodyPr wrap="square">
+            <a:spAutoFit/>
+          </a:bodyPr>
+          <a:lstStyle/>
+          <a:p>
+            <a:pPr algn="l"/>
+            <a:r>
+              <a:rPr sz="1500" b="1" i="0">
+                <a:solidFill>
+                  <a:srgbClr val="2D2D2D"/>
+                </a:solidFill>
+              </a:rPr>
+              <a:t>Normes européennes</a:t>
+            </a:r>
+          </a:p>
+        </p:txBody>
+      </p:sp>
+      <p:sp>
+        <p:nvSpPr>
+          <p:cNvPr id="30" name="TextBox 29"/>
+          <p:cNvSpPr txBox="1"/>
+          <p:nvPr/>
+        </p:nvSpPr>
+        <p:spPr>
+          <a:xfrm>
+            <a:off x="6510527" y="4709160"/>
+            <a:ext cx="5212080" cy="1417320"/>
+          </a:xfrm>
+          <a:prstGeom prst="rect">
+            <a:avLst/>
+          </a:prstGeom>
+          <a:noFill/>
+        </p:spPr>
+        <p:txBody>
+          <a:bodyPr wrap="square">
+            <a:spAutoFit/>
+          </a:bodyPr>
+          <a:lstStyle/>
+          <a:p>
+            <a:pPr algn="l"/>
+            <a:r>
+              <a:rPr sz="1200" b="0" i="0">
+                <a:solidFill>
+                  <a:srgbClr val="7A7A7A"/>
+                </a:solidFill>
+              </a:rPr>
+              <a:t>Certification EN 14960
+pour une utilisation
+en toute sérénité.</a:t>
+            </a:r>
+          </a:p>
+        </p:txBody>
+      </p:sp>
+      <p:sp>
+        <p:nvSpPr>
+          <p:cNvPr id="31" name="Rounded Rectangle 30"/>
+          <p:cNvSpPr/>
+          <p:nvPr/>
+        </p:nvSpPr>
+        <p:spPr>
+          <a:xfrm>
+            <a:off x="320040" y="6400800"/>
+            <a:ext cx="11521440" cy="347472"/>
+          </a:xfrm>
+          <a:prstGeom prst="roundRect">
+            <a:avLst>
+              <a:gd name="adj" fmla="val 8000"/>
+            </a:avLst>
+          </a:prstGeom>
+          <a:solidFill>
+            <a:srgbClr val="D6EDED"/>
+          </a:solidFill>
+          <a:ln>
+            <a:noFill/>
+          </a:ln>
+        </p:spPr>
+        <p:style>
+          <a:lnRef idx="1">
+            <a:schemeClr val="accent1"/>
+          </a:lnRef>
+          <a:fillRef idx="3">
+            <a:schemeClr val="accent1"/>
+          </a:fillRef>
+          <a:effectRef idx="2">
+            <a:schemeClr val="accent1"/>
+          </a:effectRef>
+          <a:fontRef idx="minor">
+            <a:schemeClr val="lt1"/>
+          </a:fontRef>
+        </p:style>
+        <p:txBody>
+          <a:bodyPr rtlCol="0" anchor="ctr"/>
+          <a:lstStyle/>
+          <a:p>
+            <a:pPr algn="ctr"/>
+          </a:p>
+        </p:txBody>
+      </p:sp>
+      <p:sp>
+        <p:nvSpPr>
+          <p:cNvPr id="32" name="TextBox 31"/>
+          <p:cNvSpPr txBox="1"/>
+          <p:nvPr/>
+        </p:nvSpPr>
+        <p:spPr>
+          <a:xfrm>
+            <a:off x="320040" y="6455664"/>
+            <a:ext cx="11521440" cy="274320"/>
+          </a:xfrm>
+          <a:prstGeom prst="rect">
+            <a:avLst/>
+          </a:prstGeom>
+          <a:noFill/>
+        </p:spPr>
+        <p:txBody>
+          <a:bodyPr wrap="square">
+            <a:spAutoFit/>
+          </a:bodyPr>
+          <a:lstStyle/>
+          <a:p>
+            <a:pPr algn="ctr"/>
+            <a:r>
+              <a:rPr sz="1100" b="0" i="0">
+                <a:solidFill>
+                  <a:srgbClr val="4A9E9E"/>
+                </a:solidFill>
+              </a:rPr>
+              <a:t>Pour plus d'informations : jeux-gonflables.net — Parcours gonflable occasion #1359</a:t>
             </a:r>
           </a:p>
         </p:txBody>

</xml_diff>